<commit_message>
Add substantive knowledge notes to Unit 6 PPTs
Balance guiding questions with note-worthy content: literary facts,
plot summaries, analysis methods, classical Chinese, and theme notes
per lesson, using dedicated 记笔记 slides.

Co-authored-by: Lin Silentium <decemberlin54-del@users.noreply.github.com>
</commit_message>
<xml_diff>
--- a/第六单元PPT/第10-12课时 单元成果展示.pptx
+++ b/第六单元PPT/第10-12课时 单元成果展示.pptx
@@ -11,9 +11,6 @@
     <p:sldId id="259" r:id="rId10"/>
     <p:sldId id="260" r:id="rId11"/>
     <p:sldId id="261" r:id="rId12"/>
-    <p:sldId id="262" r:id="rId13"/>
-    <p:sldId id="263" r:id="rId14"/>
-    <p:sldId id="264" r:id="rId15"/>
   </p:sldIdLst>
   <p:sldSz cx="12191695" cy="6858000" type="screen4x3"/>
   <p:notesSz cx="6858000" cy="9144000"/>
@@ -3605,7 +3602,7 @@
                 </a:solidFill>
                 <a:latin typeface="Microsoft YaHei"/>
               </a:rPr>
-              <a:t>综合研读</a:t>
+              <a:t>比较笔记</a:t>
             </a:r>
           </a:p>
         </p:txBody>
@@ -3638,13 +3635,13 @@
               </a:spcAft>
             </a:pPr>
             <a:r>
-              <a:rPr sz="3600" b="1">
+              <a:rPr sz="3400" b="1">
                 <a:solidFill>
                   <a:srgbClr val="E65096"/>
                 </a:solidFill>
                 <a:latin typeface="Microsoft YaHei"/>
               </a:rPr>
-              <a:t>第十课时</a:t>
+              <a:t>四类文本比较</a:t>
             </a:r>
           </a:p>
         </p:txBody>
@@ -3700,8 +3697,8 @@
         </p:nvSpPr>
         <p:spPr>
           <a:xfrm>
-            <a:off x="1295704" y="1645920"/>
-            <a:ext cx="9601200" cy="2240280"/>
+            <a:off x="1158544" y="1645920"/>
+            <a:ext cx="9875520" cy="2953512"/>
           </a:xfrm>
           <a:prstGeom prst="roundRect">
             <a:avLst/>
@@ -3739,57 +3736,14 @@
       </p:sp>
       <p:sp>
         <p:nvSpPr>
-          <p:cNvPr id="11" name="Oval 10"/>
-          <p:cNvSpPr/>
-          <p:nvPr/>
-        </p:nvSpPr>
-        <p:spPr>
-          <a:xfrm>
-            <a:off x="2255824" y="1828800"/>
-            <a:ext cx="384048" cy="384048"/>
-          </a:xfrm>
-          <a:prstGeom prst="ellipse">
-            <a:avLst/>
-          </a:prstGeom>
-          <a:solidFill>
-            <a:srgbClr val="E65096"/>
-          </a:solidFill>
-          <a:ln>
-            <a:noFill/>
-          </a:ln>
-        </p:spPr>
-        <p:style>
-          <a:lnRef idx="1">
-            <a:schemeClr val="accent1"/>
-          </a:lnRef>
-          <a:fillRef idx="3">
-            <a:schemeClr val="accent1"/>
-          </a:fillRef>
-          <a:effectRef idx="2">
-            <a:schemeClr val="accent1"/>
-          </a:effectRef>
-          <a:fontRef idx="minor">
-            <a:schemeClr val="lt1"/>
-          </a:fontRef>
-        </p:style>
-        <p:txBody>
-          <a:bodyPr rtlCol="0" anchor="ctr"/>
-          <a:lstStyle/>
-          <a:p>
-            <a:pPr algn="ctr"/>
-          </a:p>
-        </p:txBody>
-      </p:sp>
-      <p:sp>
-        <p:nvSpPr>
-          <p:cNvPr id="12" name="TextBox 11"/>
+          <p:cNvPr id="11" name="TextBox 10"/>
           <p:cNvSpPr txBox="1"/>
           <p:nvPr/>
         </p:nvSpPr>
         <p:spPr>
           <a:xfrm>
-            <a:off x="2255824" y="1847088"/>
-            <a:ext cx="384048" cy="365760"/>
+            <a:off x="1234440" y="1783080"/>
+            <a:ext cx="2377440" cy="502920"/>
           </a:xfrm>
           <a:prstGeom prst="rect">
             <a:avLst/>
@@ -3802,33 +3756,33 @@
           </a:bodyPr>
           <a:lstStyle/>
           <a:p>
-            <a:pPr algn="ctr">
+            <a:pPr algn="r">
               <a:spcAft>
                 <a:spcPts val="1000"/>
               </a:spcAft>
             </a:pPr>
             <a:r>
-              <a:rPr sz="1600" b="1">
+              <a:rPr sz="2200" b="1">
                 <a:solidFill>
-                  <a:srgbClr val="FFFFFF"/>
+                  <a:srgbClr val="E65096"/>
                 </a:solidFill>
                 <a:latin typeface="Microsoft YaHei"/>
               </a:rPr>
-              <a:t>1</a:t>
-            </a:r>
-          </a:p>
-        </p:txBody>
-      </p:sp>
-      <p:sp>
-        <p:nvSpPr>
-          <p:cNvPr id="13" name="TextBox 12"/>
+              <a:t>神魔小说</a:t>
+            </a:r>
+          </a:p>
+        </p:txBody>
+      </p:sp>
+      <p:sp>
+        <p:nvSpPr>
+          <p:cNvPr id="12" name="TextBox 11"/>
           <p:cNvSpPr txBox="1"/>
           <p:nvPr/>
         </p:nvSpPr>
         <p:spPr>
           <a:xfrm>
-            <a:off x="2758744" y="1810512"/>
-            <a:ext cx="7772400" cy="502920"/>
+            <a:off x="3749039" y="1783080"/>
+            <a:ext cx="7589520" cy="594360"/>
           </a:xfrm>
           <a:prstGeom prst="rect">
             <a:avLst/>
@@ -3847,70 +3801,27 @@
               </a:spcAft>
             </a:pPr>
             <a:r>
-              <a:rPr sz="2400" b="0">
+              <a:rPr sz="2200" b="0">
                 <a:solidFill>
                   <a:srgbClr val="46325A"/>
                 </a:solidFill>
                 <a:latin typeface="Microsoft YaHei"/>
               </a:rPr>
-              <a:t>比较四类文本想象的依据、表现方式和现实意味</a:t>
-            </a:r>
-          </a:p>
-        </p:txBody>
-      </p:sp>
-      <p:sp>
-        <p:nvSpPr>
-          <p:cNvPr id="14" name="Oval 13"/>
-          <p:cNvSpPr/>
-          <p:nvPr/>
-        </p:nvSpPr>
-        <p:spPr>
-          <a:xfrm>
-            <a:off x="2255824" y="2395728"/>
-            <a:ext cx="384048" cy="384048"/>
-          </a:xfrm>
-          <a:prstGeom prst="ellipse">
-            <a:avLst/>
-          </a:prstGeom>
-          <a:solidFill>
-            <a:srgbClr val="E65096"/>
-          </a:solidFill>
-          <a:ln>
-            <a:noFill/>
-          </a:ln>
-        </p:spPr>
-        <p:style>
-          <a:lnRef idx="1">
-            <a:schemeClr val="accent1"/>
-          </a:lnRef>
-          <a:fillRef idx="3">
-            <a:schemeClr val="accent1"/>
-          </a:fillRef>
-          <a:effectRef idx="2">
-            <a:schemeClr val="accent1"/>
-          </a:effectRef>
-          <a:fontRef idx="minor">
-            <a:schemeClr val="lt1"/>
-          </a:fontRef>
-        </p:style>
-        <p:txBody>
-          <a:bodyPr rtlCol="0" anchor="ctr"/>
-          <a:lstStyle/>
-          <a:p>
-            <a:pPr algn="ctr"/>
-          </a:p>
-        </p:txBody>
-      </p:sp>
-      <p:sp>
-        <p:nvSpPr>
-          <p:cNvPr id="15" name="TextBox 14"/>
+              <a:t>想象依据：相克逻辑；表现：连续变化；意味：人情世故</a:t>
+            </a:r>
+          </a:p>
+        </p:txBody>
+      </p:sp>
+      <p:sp>
+        <p:nvSpPr>
+          <p:cNvPr id="13" name="TextBox 12"/>
           <p:cNvSpPr txBox="1"/>
           <p:nvPr/>
         </p:nvSpPr>
         <p:spPr>
           <a:xfrm>
-            <a:off x="2255824" y="2414016"/>
-            <a:ext cx="384048" cy="365760"/>
+            <a:off x="1234440" y="2441448"/>
+            <a:ext cx="2377440" cy="502920"/>
           </a:xfrm>
           <a:prstGeom prst="rect">
             <a:avLst/>
@@ -3923,33 +3834,33 @@
           </a:bodyPr>
           <a:lstStyle/>
           <a:p>
-            <a:pPr algn="ctr">
+            <a:pPr algn="r">
               <a:spcAft>
                 <a:spcPts val="1000"/>
               </a:spcAft>
             </a:pPr>
             <a:r>
-              <a:rPr sz="1600" b="1">
+              <a:rPr sz="2200" b="1">
                 <a:solidFill>
-                  <a:srgbClr val="FFFFFF"/>
+                  <a:srgbClr val="E65096"/>
                 </a:solidFill>
                 <a:latin typeface="Microsoft YaHei"/>
               </a:rPr>
-              <a:t>2</a:t>
-            </a:r>
-          </a:p>
-        </p:txBody>
-      </p:sp>
-      <p:sp>
-        <p:nvSpPr>
-          <p:cNvPr id="16" name="TextBox 15"/>
+              <a:t>童话</a:t>
+            </a:r>
+          </a:p>
+        </p:txBody>
+      </p:sp>
+      <p:sp>
+        <p:nvSpPr>
+          <p:cNvPr id="14" name="TextBox 13"/>
           <p:cNvSpPr txBox="1"/>
           <p:nvPr/>
         </p:nvSpPr>
         <p:spPr>
           <a:xfrm>
-            <a:off x="2758744" y="2377440"/>
-            <a:ext cx="7772400" cy="502920"/>
+            <a:off x="3749039" y="2441448"/>
+            <a:ext cx="7589520" cy="594360"/>
           </a:xfrm>
           <a:prstGeom prst="rect">
             <a:avLst/>
@@ -3968,70 +3879,27 @@
               </a:spcAft>
             </a:pPr>
             <a:r>
-              <a:rPr sz="2400" b="0">
+              <a:rPr sz="2200" b="0">
                 <a:solidFill>
                   <a:srgbClr val="46325A"/>
                 </a:solidFill>
                 <a:latin typeface="Microsoft YaHei"/>
               </a:rPr>
-              <a:t>完成一张有文本依据的「想象说明卡」</a:t>
-            </a:r>
-          </a:p>
-        </p:txBody>
-      </p:sp>
-      <p:sp>
-        <p:nvSpPr>
-          <p:cNvPr id="17" name="Oval 16"/>
-          <p:cNvSpPr/>
-          <p:nvPr/>
-        </p:nvSpPr>
-        <p:spPr>
-          <a:xfrm>
-            <a:off x="2255824" y="2962656"/>
-            <a:ext cx="384048" cy="384048"/>
-          </a:xfrm>
-          <a:prstGeom prst="ellipse">
-            <a:avLst/>
-          </a:prstGeom>
-          <a:solidFill>
-            <a:srgbClr val="E65096"/>
-          </a:solidFill>
-          <a:ln>
-            <a:noFill/>
-          </a:ln>
-        </p:spPr>
-        <p:style>
-          <a:lnRef idx="1">
-            <a:schemeClr val="accent1"/>
-          </a:lnRef>
-          <a:fillRef idx="3">
-            <a:schemeClr val="accent1"/>
-          </a:fillRef>
-          <a:effectRef idx="2">
-            <a:schemeClr val="accent1"/>
-          </a:effectRef>
-          <a:fontRef idx="minor">
-            <a:schemeClr val="lt1"/>
-          </a:fontRef>
-        </p:style>
-        <p:txBody>
-          <a:bodyPr rtlCol="0" anchor="ctr"/>
-          <a:lstStyle/>
-          <a:p>
-            <a:pPr algn="ctr"/>
-          </a:p>
-        </p:txBody>
-      </p:sp>
-      <p:sp>
-        <p:nvSpPr>
-          <p:cNvPr id="18" name="TextBox 17"/>
+              <a:t>想象依据：生活经验；表现：夸张反讽；意味：照见人性</a:t>
+            </a:r>
+          </a:p>
+        </p:txBody>
+      </p:sp>
+      <p:sp>
+        <p:nvSpPr>
+          <p:cNvPr id="15" name="TextBox 14"/>
           <p:cNvSpPr txBox="1"/>
           <p:nvPr/>
         </p:nvSpPr>
         <p:spPr>
           <a:xfrm>
-            <a:off x="2255824" y="2980944"/>
-            <a:ext cx="384048" cy="365760"/>
+            <a:off x="1234440" y="3099815"/>
+            <a:ext cx="2377440" cy="502920"/>
           </a:xfrm>
           <a:prstGeom prst="rect">
             <a:avLst/>
@@ -4044,33 +3912,33 @@
           </a:bodyPr>
           <a:lstStyle/>
           <a:p>
-            <a:pPr algn="ctr">
+            <a:pPr algn="r">
               <a:spcAft>
                 <a:spcPts val="1000"/>
               </a:spcAft>
             </a:pPr>
             <a:r>
-              <a:rPr sz="1600" b="1">
+              <a:rPr sz="2200" b="1">
                 <a:solidFill>
-                  <a:srgbClr val="FFFFFF"/>
+                  <a:srgbClr val="E65096"/>
                 </a:solidFill>
                 <a:latin typeface="Microsoft YaHei"/>
               </a:rPr>
-              <a:t>3</a:t>
-            </a:r>
-          </a:p>
-        </p:txBody>
-      </p:sp>
-      <p:sp>
-        <p:nvSpPr>
-          <p:cNvPr id="19" name="TextBox 18"/>
+              <a:t>神话</a:t>
+            </a:r>
+          </a:p>
+        </p:txBody>
+      </p:sp>
+      <p:sp>
+        <p:nvSpPr>
+          <p:cNvPr id="16" name="TextBox 15"/>
           <p:cNvSpPr txBox="1"/>
           <p:nvPr/>
         </p:nvSpPr>
         <p:spPr>
           <a:xfrm>
-            <a:off x="2758744" y="2944368"/>
-            <a:ext cx="7772400" cy="502920"/>
+            <a:off x="3749039" y="3099815"/>
+            <a:ext cx="7589520" cy="594360"/>
           </a:xfrm>
           <a:prstGeom prst="rect">
             <a:avLst/>
@@ -4089,13 +3957,91 @@
               </a:spcAft>
             </a:pPr>
             <a:r>
-              <a:rPr sz="2400" b="0">
+              <a:rPr sz="2200" b="0">
                 <a:solidFill>
                   <a:srgbClr val="46325A"/>
                 </a:solidFill>
                 <a:latin typeface="Microsoft YaHei"/>
               </a:rPr>
-              <a:t>同伴审稿：事实准确？神奇具体？照见了什么？</a:t>
+              <a:t>想象依据：古籍传说；表现：创世画面；意味：礼赞生命</a:t>
+            </a:r>
+          </a:p>
+        </p:txBody>
+      </p:sp>
+      <p:sp>
+        <p:nvSpPr>
+          <p:cNvPr id="17" name="TextBox 16"/>
+          <p:cNvSpPr txBox="1"/>
+          <p:nvPr/>
+        </p:nvSpPr>
+        <p:spPr>
+          <a:xfrm>
+            <a:off x="1234440" y="3758184"/>
+            <a:ext cx="2377440" cy="502920"/>
+          </a:xfrm>
+          <a:prstGeom prst="rect">
+            <a:avLst/>
+          </a:prstGeom>
+          <a:noFill/>
+        </p:spPr>
+        <p:txBody>
+          <a:bodyPr wrap="none">
+            <a:spAutoFit/>
+          </a:bodyPr>
+          <a:lstStyle/>
+          <a:p>
+            <a:pPr algn="r">
+              <a:spcAft>
+                <a:spcPts val="1000"/>
+              </a:spcAft>
+            </a:pPr>
+            <a:r>
+              <a:rPr sz="2200" b="1">
+                <a:solidFill>
+                  <a:srgbClr val="E65096"/>
+                </a:solidFill>
+                <a:latin typeface="Microsoft YaHei"/>
+              </a:rPr>
+              <a:t>寓言</a:t>
+            </a:r>
+          </a:p>
+        </p:txBody>
+      </p:sp>
+      <p:sp>
+        <p:nvSpPr>
+          <p:cNvPr id="18" name="TextBox 17"/>
+          <p:cNvSpPr txBox="1"/>
+          <p:nvPr/>
+        </p:nvSpPr>
+        <p:spPr>
+          <a:xfrm>
+            <a:off x="3749039" y="3758184"/>
+            <a:ext cx="7589520" cy="594360"/>
+          </a:xfrm>
+          <a:prstGeom prst="rect">
+            <a:avLst/>
+          </a:prstGeom>
+          <a:noFill/>
+        </p:spPr>
+        <p:txBody>
+          <a:bodyPr wrap="none">
+            <a:spAutoFit/>
+          </a:bodyPr>
+          <a:lstStyle/>
+          <a:p>
+            <a:pPr algn="l">
+              <a:spcAft>
+                <a:spcPts val="1000"/>
+              </a:spcAft>
+            </a:pPr>
+            <a:r>
+              <a:rPr sz="2200" b="0">
+                <a:solidFill>
+                  <a:srgbClr val="46325A"/>
+                </a:solidFill>
+                <a:latin typeface="Microsoft YaHei"/>
+              </a:rPr>
+              <a:t>想象依据：生活现象；表现：拟人故事；意味：警醒智慧</a:t>
             </a:r>
           </a:p>
         </p:txBody>
@@ -4310,7 +4256,7 @@
                 </a:solidFill>
                 <a:latin typeface="Microsoft YaHei"/>
               </a:rPr>
-              <a:t>比较阅读</a:t>
+              <a:t>写作笔记</a:t>
             </a:r>
           </a:p>
         </p:txBody>
@@ -4343,13 +4289,13 @@
               </a:spcAft>
             </a:pPr>
             <a:r>
-              <a:rPr sz="3600" b="1">
+              <a:rPr sz="3400" b="1">
                 <a:solidFill>
                   <a:srgbClr val="E65096"/>
                 </a:solidFill>
                 <a:latin typeface="Microsoft YaHei"/>
               </a:rPr>
-              <a:t>想象的四种面貌</a:t>
+              <a:t>联想与想象</a:t>
             </a:r>
           </a:p>
         </p:txBody>
@@ -4405,8 +4351,8 @@
         </p:nvSpPr>
         <p:spPr>
           <a:xfrm>
-            <a:off x="1295704" y="1645920"/>
-            <a:ext cx="9601200" cy="2834640"/>
+            <a:off x="1158544" y="1645920"/>
+            <a:ext cx="9875520" cy="2953512"/>
           </a:xfrm>
           <a:prstGeom prst="roundRect">
             <a:avLst/>
@@ -4444,57 +4390,14 @@
       </p:sp>
       <p:sp>
         <p:nvSpPr>
-          <p:cNvPr id="11" name="Oval 10"/>
-          <p:cNvSpPr/>
-          <p:nvPr/>
-        </p:nvSpPr>
-        <p:spPr>
-          <a:xfrm>
-            <a:off x="2255824" y="1828800"/>
-            <a:ext cx="384048" cy="384048"/>
-          </a:xfrm>
-          <a:prstGeom prst="ellipse">
-            <a:avLst/>
-          </a:prstGeom>
-          <a:solidFill>
-            <a:srgbClr val="E65096"/>
-          </a:solidFill>
-          <a:ln>
-            <a:noFill/>
-          </a:ln>
-        </p:spPr>
-        <p:style>
-          <a:lnRef idx="1">
-            <a:schemeClr val="accent1"/>
-          </a:lnRef>
-          <a:fillRef idx="3">
-            <a:schemeClr val="accent1"/>
-          </a:fillRef>
-          <a:effectRef idx="2">
-            <a:schemeClr val="accent1"/>
-          </a:effectRef>
-          <a:fontRef idx="minor">
-            <a:schemeClr val="lt1"/>
-          </a:fontRef>
-        </p:style>
-        <p:txBody>
-          <a:bodyPr rtlCol="0" anchor="ctr"/>
-          <a:lstStyle/>
-          <a:p>
-            <a:pPr algn="ctr"/>
-          </a:p>
-        </p:txBody>
-      </p:sp>
-      <p:sp>
-        <p:nvSpPr>
-          <p:cNvPr id="12" name="TextBox 11"/>
+          <p:cNvPr id="11" name="TextBox 10"/>
           <p:cNvSpPr txBox="1"/>
           <p:nvPr/>
         </p:nvSpPr>
         <p:spPr>
           <a:xfrm>
-            <a:off x="2255824" y="1847088"/>
-            <a:ext cx="384048" cy="365760"/>
+            <a:off x="1234440" y="1783080"/>
+            <a:ext cx="2377440" cy="502920"/>
           </a:xfrm>
           <a:prstGeom prst="rect">
             <a:avLst/>
@@ -4507,33 +4410,33 @@
           </a:bodyPr>
           <a:lstStyle/>
           <a:p>
-            <a:pPr algn="ctr">
+            <a:pPr algn="r">
               <a:spcAft>
                 <a:spcPts val="1000"/>
               </a:spcAft>
             </a:pPr>
             <a:r>
-              <a:rPr sz="1600" b="1">
+              <a:rPr sz="2200" b="1">
                 <a:solidFill>
-                  <a:srgbClr val="FFFFFF"/>
+                  <a:srgbClr val="E65096"/>
                 </a:solidFill>
                 <a:latin typeface="Microsoft YaHei"/>
               </a:rPr>
-              <a:t>1</a:t>
-            </a:r>
-          </a:p>
-        </p:txBody>
-      </p:sp>
-      <p:sp>
-        <p:nvSpPr>
-          <p:cNvPr id="13" name="TextBox 12"/>
+              <a:t>联想</a:t>
+            </a:r>
+          </a:p>
+        </p:txBody>
+      </p:sp>
+      <p:sp>
+        <p:nvSpPr>
+          <p:cNvPr id="12" name="TextBox 11"/>
           <p:cNvSpPr txBox="1"/>
           <p:nvPr/>
         </p:nvSpPr>
         <p:spPr>
           <a:xfrm>
-            <a:off x="2758744" y="1810512"/>
-            <a:ext cx="7772400" cy="502920"/>
+            <a:off x="3749039" y="1783080"/>
+            <a:ext cx="7589520" cy="594360"/>
           </a:xfrm>
           <a:prstGeom prst="rect">
             <a:avLst/>
@@ -4552,70 +4455,27 @@
               </a:spcAft>
             </a:pPr>
             <a:r>
-              <a:rPr sz="2400" b="0">
+              <a:rPr sz="2200" b="0">
                 <a:solidFill>
                   <a:srgbClr val="46325A"/>
                 </a:solidFill>
                 <a:latin typeface="Microsoft YaHei"/>
               </a:rPr>
-              <a:t>神魔小说：变化斗法，人情世故</a:t>
-            </a:r>
-          </a:p>
-        </p:txBody>
-      </p:sp>
-      <p:sp>
-        <p:nvSpPr>
-          <p:cNvPr id="14" name="Oval 13"/>
-          <p:cNvSpPr/>
-          <p:nvPr/>
-        </p:nvSpPr>
-        <p:spPr>
-          <a:xfrm>
-            <a:off x="2255824" y="2395728"/>
-            <a:ext cx="384048" cy="384048"/>
-          </a:xfrm>
-          <a:prstGeom prst="ellipse">
-            <a:avLst/>
-          </a:prstGeom>
-          <a:solidFill>
-            <a:srgbClr val="E65096"/>
-          </a:solidFill>
-          <a:ln>
-            <a:noFill/>
-          </a:ln>
-        </p:spPr>
-        <p:style>
-          <a:lnRef idx="1">
-            <a:schemeClr val="accent1"/>
-          </a:lnRef>
-          <a:fillRef idx="3">
-            <a:schemeClr val="accent1"/>
-          </a:fillRef>
-          <a:effectRef idx="2">
-            <a:schemeClr val="accent1"/>
-          </a:effectRef>
-          <a:fontRef idx="minor">
-            <a:schemeClr val="lt1"/>
-          </a:fontRef>
-        </p:style>
-        <p:txBody>
-          <a:bodyPr rtlCol="0" anchor="ctr"/>
-          <a:lstStyle/>
-          <a:p>
-            <a:pPr algn="ctr"/>
-          </a:p>
-        </p:txBody>
-      </p:sp>
-      <p:sp>
-        <p:nvSpPr>
-          <p:cNvPr id="15" name="TextBox 14"/>
+              <a:t>由一事物想到另一事物（街灯→明星，因形状相似）</a:t>
+            </a:r>
+          </a:p>
+        </p:txBody>
+      </p:sp>
+      <p:sp>
+        <p:nvSpPr>
+          <p:cNvPr id="13" name="TextBox 12"/>
           <p:cNvSpPr txBox="1"/>
           <p:nvPr/>
         </p:nvSpPr>
         <p:spPr>
           <a:xfrm>
-            <a:off x="2255824" y="2414016"/>
-            <a:ext cx="384048" cy="365760"/>
+            <a:off x="1234440" y="2441448"/>
+            <a:ext cx="2377440" cy="502920"/>
           </a:xfrm>
           <a:prstGeom prst="rect">
             <a:avLst/>
@@ -4628,33 +4488,33 @@
           </a:bodyPr>
           <a:lstStyle/>
           <a:p>
-            <a:pPr algn="ctr">
+            <a:pPr algn="r">
               <a:spcAft>
                 <a:spcPts val="1000"/>
               </a:spcAft>
             </a:pPr>
             <a:r>
-              <a:rPr sz="1600" b="1">
+              <a:rPr sz="2200" b="1">
                 <a:solidFill>
-                  <a:srgbClr val="FFFFFF"/>
+                  <a:srgbClr val="E65096"/>
                 </a:solidFill>
                 <a:latin typeface="Microsoft YaHei"/>
               </a:rPr>
-              <a:t>2</a:t>
-            </a:r>
-          </a:p>
-        </p:txBody>
-      </p:sp>
-      <p:sp>
-        <p:nvSpPr>
-          <p:cNvPr id="16" name="TextBox 15"/>
+              <a:t>想象</a:t>
+            </a:r>
+          </a:p>
+        </p:txBody>
+      </p:sp>
+      <p:sp>
+        <p:nvSpPr>
+          <p:cNvPr id="14" name="TextBox 13"/>
           <p:cNvSpPr txBox="1"/>
           <p:nvPr/>
         </p:nvSpPr>
         <p:spPr>
           <a:xfrm>
-            <a:off x="2758744" y="2377440"/>
-            <a:ext cx="7772400" cy="502920"/>
+            <a:off x="3749039" y="2441448"/>
+            <a:ext cx="7589520" cy="594360"/>
           </a:xfrm>
           <a:prstGeom prst="rect">
             <a:avLst/>
@@ -4673,70 +4533,27 @@
               </a:spcAft>
             </a:pPr>
             <a:r>
-              <a:rPr sz="2400" b="0">
+              <a:rPr sz="2200" b="0">
                 <a:solidFill>
                   <a:srgbClr val="46325A"/>
                 </a:solidFill>
                 <a:latin typeface="Microsoft YaHei"/>
               </a:rPr>
-              <a:t>童话：夸张反讽，照见人性</a:t>
-            </a:r>
-          </a:p>
-        </p:txBody>
-      </p:sp>
-      <p:sp>
-        <p:nvSpPr>
-          <p:cNvPr id="17" name="Oval 16"/>
-          <p:cNvSpPr/>
-          <p:nvPr/>
-        </p:nvSpPr>
-        <p:spPr>
-          <a:xfrm>
-            <a:off x="2255824" y="2962656"/>
-            <a:ext cx="384048" cy="384048"/>
-          </a:xfrm>
-          <a:prstGeom prst="ellipse">
-            <a:avLst/>
-          </a:prstGeom>
-          <a:solidFill>
-            <a:srgbClr val="E65096"/>
-          </a:solidFill>
-          <a:ln>
-            <a:noFill/>
-          </a:ln>
-        </p:spPr>
-        <p:style>
-          <a:lnRef idx="1">
-            <a:schemeClr val="accent1"/>
-          </a:lnRef>
-          <a:fillRef idx="3">
-            <a:schemeClr val="accent1"/>
-          </a:fillRef>
-          <a:effectRef idx="2">
-            <a:schemeClr val="accent1"/>
-          </a:effectRef>
-          <a:fontRef idx="minor">
-            <a:schemeClr val="lt1"/>
-          </a:fontRef>
-        </p:style>
-        <p:txBody>
-          <a:bodyPr rtlCol="0" anchor="ctr"/>
-          <a:lstStyle/>
-          <a:p>
-            <a:pPr algn="ctr"/>
-          </a:p>
-        </p:txBody>
-      </p:sp>
-      <p:sp>
-        <p:nvSpPr>
-          <p:cNvPr id="18" name="TextBox 17"/>
+              <a:t>在已有材料上创造新形象（天上的街市、牛郎织女骑牛）</a:t>
+            </a:r>
+          </a:p>
+        </p:txBody>
+      </p:sp>
+      <p:sp>
+        <p:nvSpPr>
+          <p:cNvPr id="15" name="TextBox 14"/>
           <p:cNvSpPr txBox="1"/>
           <p:nvPr/>
         </p:nvSpPr>
         <p:spPr>
           <a:xfrm>
-            <a:off x="2255824" y="2980944"/>
-            <a:ext cx="384048" cy="365760"/>
+            <a:off x="1234440" y="3099815"/>
+            <a:ext cx="2377440" cy="502920"/>
           </a:xfrm>
           <a:prstGeom prst="rect">
             <a:avLst/>
@@ -4749,33 +4566,33 @@
           </a:bodyPr>
           <a:lstStyle/>
           <a:p>
-            <a:pPr algn="ctr">
+            <a:pPr algn="r">
               <a:spcAft>
                 <a:spcPts val="1000"/>
               </a:spcAft>
             </a:pPr>
             <a:r>
-              <a:rPr sz="1600" b="1">
+              <a:rPr sz="2200" b="1">
                 <a:solidFill>
-                  <a:srgbClr val="FFFFFF"/>
+                  <a:srgbClr val="E65096"/>
                 </a:solidFill>
                 <a:latin typeface="Microsoft YaHei"/>
               </a:rPr>
-              <a:t>3</a:t>
-            </a:r>
-          </a:p>
-        </p:txBody>
-      </p:sp>
-      <p:sp>
-        <p:nvSpPr>
-          <p:cNvPr id="19" name="TextBox 18"/>
+              <a:t>写作要求</a:t>
+            </a:r>
+          </a:p>
+        </p:txBody>
+      </p:sp>
+      <p:sp>
+        <p:nvSpPr>
+          <p:cNvPr id="16" name="TextBox 15"/>
           <p:cNvSpPr txBox="1"/>
           <p:nvPr/>
         </p:nvSpPr>
         <p:spPr>
           <a:xfrm>
-            <a:off x="2758744" y="2944368"/>
-            <a:ext cx="7772400" cy="502920"/>
+            <a:off x="3749039" y="3099815"/>
+            <a:ext cx="7589520" cy="594360"/>
           </a:xfrm>
           <a:prstGeom prst="rect">
             <a:avLst/>
@@ -4794,70 +4611,27 @@
               </a:spcAft>
             </a:pPr>
             <a:r>
-              <a:rPr sz="2400" b="0">
+              <a:rPr sz="2200" b="0">
                 <a:solidFill>
                   <a:srgbClr val="46325A"/>
                 </a:solidFill>
                 <a:latin typeface="Microsoft YaHei"/>
               </a:rPr>
-              <a:t>神话：创世温情，生命礼赞</a:t>
-            </a:r>
-          </a:p>
-        </p:txBody>
-      </p:sp>
-      <p:sp>
-        <p:nvSpPr>
-          <p:cNvPr id="20" name="Oval 19"/>
-          <p:cNvSpPr/>
-          <p:nvPr/>
-        </p:nvSpPr>
-        <p:spPr>
-          <a:xfrm>
-            <a:off x="2255824" y="3529584"/>
-            <a:ext cx="384048" cy="384048"/>
-          </a:xfrm>
-          <a:prstGeom prst="ellipse">
-            <a:avLst/>
-          </a:prstGeom>
-          <a:solidFill>
-            <a:srgbClr val="E65096"/>
-          </a:solidFill>
-          <a:ln>
-            <a:noFill/>
-          </a:ln>
-        </p:spPr>
-        <p:style>
-          <a:lnRef idx="1">
-            <a:schemeClr val="accent1"/>
-          </a:lnRef>
-          <a:fillRef idx="3">
-            <a:schemeClr val="accent1"/>
-          </a:fillRef>
-          <a:effectRef idx="2">
-            <a:schemeClr val="accent1"/>
-          </a:effectRef>
-          <a:fontRef idx="minor">
-            <a:schemeClr val="lt1"/>
-          </a:fontRef>
-        </p:style>
-        <p:txBody>
-          <a:bodyPr rtlCol="0" anchor="ctr"/>
-          <a:lstStyle/>
-          <a:p>
-            <a:pPr algn="ctr"/>
-          </a:p>
-        </p:txBody>
-      </p:sp>
-      <p:sp>
-        <p:nvSpPr>
-          <p:cNvPr id="21" name="TextBox 20"/>
+              <a:t>有依据、合逻辑、有新意</a:t>
+            </a:r>
+          </a:p>
+        </p:txBody>
+      </p:sp>
+      <p:sp>
+        <p:nvSpPr>
+          <p:cNvPr id="17" name="TextBox 16"/>
           <p:cNvSpPr txBox="1"/>
           <p:nvPr/>
         </p:nvSpPr>
         <p:spPr>
           <a:xfrm>
-            <a:off x="2255824" y="3547872"/>
-            <a:ext cx="384048" cy="365760"/>
+            <a:off x="1234440" y="3758184"/>
+            <a:ext cx="2377440" cy="502920"/>
           </a:xfrm>
           <a:prstGeom prst="rect">
             <a:avLst/>
@@ -4870,33 +4644,33 @@
           </a:bodyPr>
           <a:lstStyle/>
           <a:p>
-            <a:pPr algn="ctr">
+            <a:pPr algn="r">
               <a:spcAft>
                 <a:spcPts val="1000"/>
               </a:spcAft>
             </a:pPr>
             <a:r>
-              <a:rPr sz="1600" b="1">
+              <a:rPr sz="2200" b="1">
                 <a:solidFill>
-                  <a:srgbClr val="FFFFFF"/>
+                  <a:srgbClr val="E65096"/>
                 </a:solidFill>
                 <a:latin typeface="Microsoft YaHei"/>
               </a:rPr>
-              <a:t>4</a:t>
-            </a:r>
-          </a:p>
-        </p:txBody>
-      </p:sp>
-      <p:sp>
-        <p:nvSpPr>
-          <p:cNvPr id="22" name="TextBox 21"/>
+              <a:t>创作路径</a:t>
+            </a:r>
+          </a:p>
+        </p:txBody>
+      </p:sp>
+      <p:sp>
+        <p:nvSpPr>
+          <p:cNvPr id="18" name="TextBox 17"/>
           <p:cNvSpPr txBox="1"/>
           <p:nvPr/>
         </p:nvSpPr>
         <p:spPr>
           <a:xfrm>
-            <a:off x="2758744" y="3511296"/>
-            <a:ext cx="7772400" cy="502920"/>
+            <a:off x="3749039" y="3758184"/>
+            <a:ext cx="7589520" cy="594360"/>
           </a:xfrm>
           <a:prstGeom prst="rect">
             <a:avLst/>
@@ -4915,13 +4689,13 @@
               </a:spcAft>
             </a:pPr>
             <a:r>
-              <a:rPr sz="2400" b="0">
+              <a:rPr sz="2200" b="0">
                 <a:solidFill>
                   <a:srgbClr val="46325A"/>
                 </a:solidFill>
                 <a:latin typeface="Microsoft YaHei"/>
               </a:rPr>
-              <a:t>寓言：简短警醒，寓意深远</a:t>
+              <a:t>触发点→联想链→情节转折→表达主题</a:t>
             </a:r>
           </a:p>
         </p:txBody>
@@ -5136,7 +4910,7 @@
                 </a:solidFill>
                 <a:latin typeface="Microsoft YaHei"/>
               </a:rPr>
-              <a:t>写作训练</a:t>
+              <a:t>策展笔记</a:t>
             </a:r>
           </a:p>
         </p:txBody>
@@ -5169,13 +4943,13 @@
               </a:spcAft>
             </a:pPr>
             <a:r>
-              <a:rPr sz="3600" b="1">
+              <a:rPr sz="3400" b="1">
                 <a:solidFill>
                   <a:srgbClr val="E65096"/>
                 </a:solidFill>
                 <a:latin typeface="Microsoft YaHei"/>
               </a:rPr>
-              <a:t>第十一课时</a:t>
+              <a:t>想象说明卡</a:t>
             </a:r>
           </a:p>
         </p:txBody>
@@ -5231,8 +5005,8 @@
         </p:nvSpPr>
         <p:spPr>
           <a:xfrm>
-            <a:off x="1295704" y="1645920"/>
-            <a:ext cx="9601200" cy="2240280"/>
+            <a:off x="1158544" y="1645920"/>
+            <a:ext cx="9875520" cy="2953512"/>
           </a:xfrm>
           <a:prstGeom prst="roundRect">
             <a:avLst/>
@@ -5270,57 +5044,14 @@
       </p:sp>
       <p:sp>
         <p:nvSpPr>
-          <p:cNvPr id="11" name="Oval 10"/>
-          <p:cNvSpPr/>
-          <p:nvPr/>
-        </p:nvSpPr>
-        <p:spPr>
-          <a:xfrm>
-            <a:off x="2255824" y="1828800"/>
-            <a:ext cx="384048" cy="384048"/>
-          </a:xfrm>
-          <a:prstGeom prst="ellipse">
-            <a:avLst/>
-          </a:prstGeom>
-          <a:solidFill>
-            <a:srgbClr val="E65096"/>
-          </a:solidFill>
-          <a:ln>
-            <a:noFill/>
-          </a:ln>
-        </p:spPr>
-        <p:style>
-          <a:lnRef idx="1">
-            <a:schemeClr val="accent1"/>
-          </a:lnRef>
-          <a:fillRef idx="3">
-            <a:schemeClr val="accent1"/>
-          </a:fillRef>
-          <a:effectRef idx="2">
-            <a:schemeClr val="accent1"/>
-          </a:effectRef>
-          <a:fontRef idx="minor">
-            <a:schemeClr val="lt1"/>
-          </a:fontRef>
-        </p:style>
-        <p:txBody>
-          <a:bodyPr rtlCol="0" anchor="ctr"/>
-          <a:lstStyle/>
-          <a:p>
-            <a:pPr algn="ctr"/>
-          </a:p>
-        </p:txBody>
-      </p:sp>
-      <p:sp>
-        <p:nvSpPr>
-          <p:cNvPr id="12" name="TextBox 11"/>
+          <p:cNvPr id="11" name="TextBox 10"/>
           <p:cNvSpPr txBox="1"/>
           <p:nvPr/>
         </p:nvSpPr>
         <p:spPr>
           <a:xfrm>
-            <a:off x="2255824" y="1847088"/>
-            <a:ext cx="384048" cy="365760"/>
+            <a:off x="1234440" y="1783080"/>
+            <a:ext cx="2377440" cy="502920"/>
           </a:xfrm>
           <a:prstGeom prst="rect">
             <a:avLst/>
@@ -5333,33 +5064,33 @@
           </a:bodyPr>
           <a:lstStyle/>
           <a:p>
-            <a:pPr algn="ctr">
+            <a:pPr algn="r">
               <a:spcAft>
                 <a:spcPts val="1000"/>
               </a:spcAft>
             </a:pPr>
             <a:r>
-              <a:rPr sz="1600" b="1">
+              <a:rPr sz="2200" b="1">
                 <a:solidFill>
-                  <a:srgbClr val="FFFFFF"/>
+                  <a:srgbClr val="E65096"/>
                 </a:solidFill>
                 <a:latin typeface="Microsoft YaHei"/>
               </a:rPr>
-              <a:t>1</a:t>
-            </a:r>
-          </a:p>
-        </p:txBody>
-      </p:sp>
-      <p:sp>
-        <p:nvSpPr>
-          <p:cNvPr id="13" name="TextBox 12"/>
+              <a:t>文本片段</a:t>
+            </a:r>
+          </a:p>
+        </p:txBody>
+      </p:sp>
+      <p:sp>
+        <p:nvSpPr>
+          <p:cNvPr id="12" name="TextBox 11"/>
           <p:cNvSpPr txBox="1"/>
           <p:nvPr/>
         </p:nvSpPr>
         <p:spPr>
           <a:xfrm>
-            <a:off x="2758744" y="1810512"/>
-            <a:ext cx="7772400" cy="502920"/>
+            <a:off x="3749039" y="1783080"/>
+            <a:ext cx="7589520" cy="594360"/>
           </a:xfrm>
           <a:prstGeom prst="rect">
             <a:avLst/>
@@ -5378,70 +5109,27 @@
               </a:spcAft>
             </a:pPr>
             <a:r>
-              <a:rPr sz="2400" b="0">
+              <a:rPr sz="2200" b="0">
                 <a:solidFill>
                   <a:srgbClr val="46325A"/>
                 </a:solidFill>
                 <a:latin typeface="Microsoft YaHei"/>
               </a:rPr>
-              <a:t>朗读《天上的街市》，辨析联想与想象</a:t>
-            </a:r>
-          </a:p>
-        </p:txBody>
-      </p:sp>
-      <p:sp>
-        <p:nvSpPr>
-          <p:cNvPr id="14" name="Oval 13"/>
-          <p:cNvSpPr/>
-          <p:nvPr/>
-        </p:nvSpPr>
-        <p:spPr>
-          <a:xfrm>
-            <a:off x="2255824" y="2395728"/>
-            <a:ext cx="384048" cy="384048"/>
-          </a:xfrm>
-          <a:prstGeom prst="ellipse">
-            <a:avLst/>
-          </a:prstGeom>
-          <a:solidFill>
-            <a:srgbClr val="E65096"/>
-          </a:solidFill>
-          <a:ln>
-            <a:noFill/>
-          </a:ln>
-        </p:spPr>
-        <p:style>
-          <a:lnRef idx="1">
-            <a:schemeClr val="accent1"/>
-          </a:lnRef>
-          <a:fillRef idx="3">
-            <a:schemeClr val="accent1"/>
-          </a:fillRef>
-          <a:effectRef idx="2">
-            <a:schemeClr val="accent1"/>
-          </a:effectRef>
-          <a:fontRef idx="minor">
-            <a:schemeClr val="lt1"/>
-          </a:fontRef>
-        </p:style>
-        <p:txBody>
-          <a:bodyPr rtlCol="0" anchor="ctr"/>
-          <a:lstStyle/>
-          <a:p>
-            <a:pPr algn="ctr"/>
-          </a:p>
-        </p:txBody>
-      </p:sp>
-      <p:sp>
-        <p:nvSpPr>
-          <p:cNvPr id="15" name="TextBox 14"/>
+              <a:t>从本单元选一个精彩片段</a:t>
+            </a:r>
+          </a:p>
+        </p:txBody>
+      </p:sp>
+      <p:sp>
+        <p:nvSpPr>
+          <p:cNvPr id="13" name="TextBox 12"/>
           <p:cNvSpPr txBox="1"/>
           <p:nvPr/>
         </p:nvSpPr>
         <p:spPr>
           <a:xfrm>
-            <a:off x="2255824" y="2414016"/>
-            <a:ext cx="384048" cy="365760"/>
+            <a:off x="1234440" y="2441448"/>
+            <a:ext cx="2377440" cy="502920"/>
           </a:xfrm>
           <a:prstGeom prst="rect">
             <a:avLst/>
@@ -5454,33 +5142,33 @@
           </a:bodyPr>
           <a:lstStyle/>
           <a:p>
-            <a:pPr algn="ctr">
+            <a:pPr algn="r">
               <a:spcAft>
                 <a:spcPts val="1000"/>
               </a:spcAft>
             </a:pPr>
             <a:r>
-              <a:rPr sz="1600" b="1">
+              <a:rPr sz="2200" b="1">
                 <a:solidFill>
-                  <a:srgbClr val="FFFFFF"/>
+                  <a:srgbClr val="E65096"/>
                 </a:solidFill>
                 <a:latin typeface="Microsoft YaHei"/>
               </a:rPr>
-              <a:t>2</a:t>
-            </a:r>
-          </a:p>
-        </p:txBody>
-      </p:sp>
-      <p:sp>
-        <p:nvSpPr>
-          <p:cNvPr id="16" name="TextBox 15"/>
+              <a:t>想象依据</a:t>
+            </a:r>
+          </a:p>
+        </p:txBody>
+      </p:sp>
+      <p:sp>
+        <p:nvSpPr>
+          <p:cNvPr id="14" name="TextBox 13"/>
           <p:cNvSpPr txBox="1"/>
           <p:nvPr/>
         </p:nvSpPr>
         <p:spPr>
           <a:xfrm>
-            <a:off x="2758744" y="2377440"/>
-            <a:ext cx="7772400" cy="502920"/>
+            <a:off x="3749039" y="2441448"/>
+            <a:ext cx="7589520" cy="594360"/>
           </a:xfrm>
           <a:prstGeom prst="rect">
             <a:avLst/>
@@ -5499,70 +5187,27 @@
               </a:spcAft>
             </a:pPr>
             <a:r>
-              <a:rPr sz="2400" b="0">
+              <a:rPr sz="2200" b="0">
                 <a:solidFill>
                   <a:srgbClr val="46325A"/>
                 </a:solidFill>
                 <a:latin typeface="Microsoft YaHei"/>
               </a:rPr>
-              <a:t>三项要求：有依据、合逻辑、有新意</a:t>
-            </a:r>
-          </a:p>
-        </p:txBody>
-      </p:sp>
-      <p:sp>
-        <p:nvSpPr>
-          <p:cNvPr id="17" name="Oval 16"/>
-          <p:cNvSpPr/>
-          <p:nvPr/>
-        </p:nvSpPr>
-        <p:spPr>
-          <a:xfrm>
-            <a:off x="2255824" y="2962656"/>
-            <a:ext cx="384048" cy="384048"/>
-          </a:xfrm>
-          <a:prstGeom prst="ellipse">
-            <a:avLst/>
-          </a:prstGeom>
-          <a:solidFill>
-            <a:srgbClr val="E65096"/>
-          </a:solidFill>
-          <a:ln>
-            <a:noFill/>
-          </a:ln>
-        </p:spPr>
-        <p:style>
-          <a:lnRef idx="1">
-            <a:schemeClr val="accent1"/>
-          </a:lnRef>
-          <a:fillRef idx="3">
-            <a:schemeClr val="accent1"/>
-          </a:fillRef>
-          <a:effectRef idx="2">
-            <a:schemeClr val="accent1"/>
-          </a:effectRef>
-          <a:fontRef idx="minor">
-            <a:schemeClr val="lt1"/>
-          </a:fontRef>
-        </p:style>
-        <p:txBody>
-          <a:bodyPr rtlCol="0" anchor="ctr"/>
-          <a:lstStyle/>
-          <a:p>
-            <a:pPr algn="ctr"/>
-          </a:p>
-        </p:txBody>
-      </p:sp>
-      <p:sp>
-        <p:nvSpPr>
-          <p:cNvPr id="18" name="TextBox 17"/>
+              <a:t>它从什么现实经验或材料出发？</a:t>
+            </a:r>
+          </a:p>
+        </p:txBody>
+      </p:sp>
+      <p:sp>
+        <p:nvSpPr>
+          <p:cNvPr id="15" name="TextBox 14"/>
           <p:cNvSpPr txBox="1"/>
           <p:nvPr/>
         </p:nvSpPr>
         <p:spPr>
           <a:xfrm>
-            <a:off x="2255824" y="2980944"/>
-            <a:ext cx="384048" cy="365760"/>
+            <a:off x="1234440" y="3099815"/>
+            <a:ext cx="2377440" cy="502920"/>
           </a:xfrm>
           <a:prstGeom prst="rect">
             <a:avLst/>
@@ -5575,33 +5220,33 @@
           </a:bodyPr>
           <a:lstStyle/>
           <a:p>
-            <a:pPr algn="ctr">
+            <a:pPr algn="r">
               <a:spcAft>
                 <a:spcPts val="1000"/>
               </a:spcAft>
             </a:pPr>
             <a:r>
-              <a:rPr sz="1600" b="1">
+              <a:rPr sz="2200" b="1">
                 <a:solidFill>
-                  <a:srgbClr val="FFFFFF"/>
+                  <a:srgbClr val="E65096"/>
                 </a:solidFill>
                 <a:latin typeface="Microsoft YaHei"/>
               </a:rPr>
-              <a:t>3</a:t>
-            </a:r>
-          </a:p>
-        </p:txBody>
-      </p:sp>
-      <p:sp>
-        <p:nvSpPr>
-          <p:cNvPr id="19" name="TextBox 18"/>
+              <a:t>表现方式</a:t>
+            </a:r>
+          </a:p>
+        </p:txBody>
+      </p:sp>
+      <p:sp>
+        <p:nvSpPr>
+          <p:cNvPr id="16" name="TextBox 15"/>
           <p:cNvSpPr txBox="1"/>
           <p:nvPr/>
         </p:nvSpPr>
         <p:spPr>
           <a:xfrm>
-            <a:off x="2758744" y="2944368"/>
-            <a:ext cx="7772400" cy="502920"/>
+            <a:off x="3749039" y="3099815"/>
+            <a:ext cx="7589520" cy="594360"/>
           </a:xfrm>
           <a:prstGeom prst="rect">
             <a:avLst/>
@@ -5620,13 +5265,91 @@
               </a:spcAft>
             </a:pPr>
             <a:r>
-              <a:rPr sz="2400" b="0">
+              <a:rPr sz="2200" b="0">
                 <a:solidFill>
                   <a:srgbClr val="46325A"/>
                 </a:solidFill>
                 <a:latin typeface="Microsoft YaHei"/>
               </a:rPr>
-              <a:t>完成创作提纲，独立写作不少于300字</a:t>
+              <a:t>用了什么手法？（变化/夸张/改写/拟人）</a:t>
+            </a:r>
+          </a:p>
+        </p:txBody>
+      </p:sp>
+      <p:sp>
+        <p:nvSpPr>
+          <p:cNvPr id="17" name="TextBox 16"/>
+          <p:cNvSpPr txBox="1"/>
+          <p:nvPr/>
+        </p:nvSpPr>
+        <p:spPr>
+          <a:xfrm>
+            <a:off x="1234440" y="3758184"/>
+            <a:ext cx="2377440" cy="502920"/>
+          </a:xfrm>
+          <a:prstGeom prst="rect">
+            <a:avLst/>
+          </a:prstGeom>
+          <a:noFill/>
+        </p:spPr>
+        <p:txBody>
+          <a:bodyPr wrap="none">
+            <a:spAutoFit/>
+          </a:bodyPr>
+          <a:lstStyle/>
+          <a:p>
+            <a:pPr algn="r">
+              <a:spcAft>
+                <a:spcPts val="1000"/>
+              </a:spcAft>
+            </a:pPr>
+            <a:r>
+              <a:rPr sz="2200" b="1">
+                <a:solidFill>
+                  <a:srgbClr val="E65096"/>
+                </a:solidFill>
+                <a:latin typeface="Microsoft YaHei"/>
+              </a:rPr>
+              <a:t>现实意味</a:t>
+            </a:r>
+          </a:p>
+        </p:txBody>
+      </p:sp>
+      <p:sp>
+        <p:nvSpPr>
+          <p:cNvPr id="18" name="TextBox 17"/>
+          <p:cNvSpPr txBox="1"/>
+          <p:nvPr/>
+        </p:nvSpPr>
+        <p:spPr>
+          <a:xfrm>
+            <a:off x="3749039" y="3758184"/>
+            <a:ext cx="7589520" cy="594360"/>
+          </a:xfrm>
+          <a:prstGeom prst="rect">
+            <a:avLst/>
+          </a:prstGeom>
+          <a:noFill/>
+        </p:spPr>
+        <p:txBody>
+          <a:bodyPr wrap="none">
+            <a:spAutoFit/>
+          </a:bodyPr>
+          <a:lstStyle/>
+          <a:p>
+            <a:pPr algn="l">
+              <a:spcAft>
+                <a:spcPts val="1000"/>
+              </a:spcAft>
+            </a:pPr>
+            <a:r>
+              <a:rPr sz="2200" b="0">
+                <a:solidFill>
+                  <a:srgbClr val="46325A"/>
+                </a:solidFill>
+                <a:latin typeface="Microsoft YaHei"/>
+              </a:rPr>
+              <a:t>照见了怎样的生活道理？（联系策展主题）</a:t>
             </a:r>
           </a:p>
         </p:txBody>
@@ -5772,7 +5495,7 @@
         </p:nvSpPr>
         <p:spPr>
           <a:xfrm>
-            <a:off x="4953304" y="1005840"/>
+            <a:off x="4953304" y="502920"/>
             <a:ext cx="2286000" cy="411480"/>
           </a:xfrm>
           <a:prstGeom prst="roundRect">
@@ -5815,7 +5538,7 @@
         </p:nvSpPr>
         <p:spPr>
           <a:xfrm>
-            <a:off x="4953304" y="1024128"/>
+            <a:off x="4953304" y="521208"/>
             <a:ext cx="2286000" cy="384048"/>
           </a:xfrm>
           <a:prstGeom prst="rect">
@@ -5841,7 +5564,7 @@
                 </a:solidFill>
                 <a:latin typeface="Microsoft YaHei"/>
               </a:rPr>
-              <a:t>想一想</a:t>
+              <a:t>展示活动</a:t>
             </a:r>
           </a:p>
         </p:txBody>
@@ -5854,7 +5577,7 @@
         </p:nvSpPr>
         <p:spPr>
           <a:xfrm>
-            <a:off x="1371600" y="1600200"/>
+            <a:off x="1371600" y="960120"/>
             <a:ext cx="9418320" cy="822960"/>
           </a:xfrm>
           <a:prstGeom prst="rect">
@@ -5874,14 +5597,13 @@
               </a:spcAft>
             </a:pPr>
             <a:r>
-              <a:rPr sz="3200" b="1">
+              <a:rPr sz="3600" b="1">
                 <a:solidFill>
                   <a:srgbClr val="E65096"/>
                 </a:solidFill>
                 <a:latin typeface="Microsoft YaHei"/>
               </a:rPr>
-              <a:t>联想是搭桥，想象是飞翔
-你的作品从哪里起飞？</a:t>
+              <a:t>成果展示要求</a:t>
             </a:r>
           </a:p>
         </p:txBody>
@@ -5894,7 +5616,7 @@
         </p:nvSpPr>
         <p:spPr>
           <a:xfrm>
-            <a:off x="3200400" y="4389120"/>
+            <a:off x="3200400" y="1600200"/>
             <a:ext cx="5760720" cy="27432"/>
           </a:xfrm>
           <a:prstGeom prst="rect">
@@ -5931,14 +5653,102 @@
       </p:sp>
       <p:sp>
         <p:nvSpPr>
-          <p:cNvPr id="10" name="TextBox 9"/>
+          <p:cNvPr id="10" name="Rounded Rectangle 9"/>
+          <p:cNvSpPr/>
+          <p:nvPr/>
+        </p:nvSpPr>
+        <p:spPr>
+          <a:xfrm>
+            <a:off x="1295704" y="1645920"/>
+            <a:ext cx="9601200" cy="2112264"/>
+          </a:xfrm>
+          <a:prstGeom prst="roundRect">
+            <a:avLst/>
+          </a:prstGeom>
+          <a:solidFill>
+            <a:srgbClr val="FFFAFF"/>
+          </a:solidFill>
+          <a:ln w="19050">
+            <a:solidFill>
+              <a:srgbClr val="64C8DC"/>
+            </a:solidFill>
+          </a:ln>
+        </p:spPr>
+        <p:style>
+          <a:lnRef idx="1">
+            <a:schemeClr val="accent1"/>
+          </a:lnRef>
+          <a:fillRef idx="3">
+            <a:schemeClr val="accent1"/>
+          </a:fillRef>
+          <a:effectRef idx="2">
+            <a:schemeClr val="accent1"/>
+          </a:effectRef>
+          <a:fontRef idx="minor">
+            <a:schemeClr val="lt1"/>
+          </a:fontRef>
+        </p:style>
+        <p:txBody>
+          <a:bodyPr rtlCol="0" anchor="ctr"/>
+          <a:lstStyle/>
+          <a:p>
+            <a:pPr algn="ctr"/>
+          </a:p>
+        </p:txBody>
+      </p:sp>
+      <p:sp>
+        <p:nvSpPr>
+          <p:cNvPr id="11" name="Oval 10"/>
+          <p:cNvSpPr/>
+          <p:nvPr/>
+        </p:nvSpPr>
+        <p:spPr>
+          <a:xfrm>
+            <a:off x="2255824" y="1828800"/>
+            <a:ext cx="347472" cy="347472"/>
+          </a:xfrm>
+          <a:prstGeom prst="ellipse">
+            <a:avLst/>
+          </a:prstGeom>
+          <a:solidFill>
+            <a:srgbClr val="E65096"/>
+          </a:solidFill>
+          <a:ln>
+            <a:noFill/>
+          </a:ln>
+        </p:spPr>
+        <p:style>
+          <a:lnRef idx="1">
+            <a:schemeClr val="accent1"/>
+          </a:lnRef>
+          <a:fillRef idx="3">
+            <a:schemeClr val="accent1"/>
+          </a:fillRef>
+          <a:effectRef idx="2">
+            <a:schemeClr val="accent1"/>
+          </a:effectRef>
+          <a:fontRef idx="minor">
+            <a:schemeClr val="lt1"/>
+          </a:fontRef>
+        </p:style>
+        <p:txBody>
+          <a:bodyPr rtlCol="0" anchor="ctr"/>
+          <a:lstStyle/>
+          <a:p>
+            <a:pPr algn="ctr"/>
+          </a:p>
+        </p:txBody>
+      </p:sp>
+      <p:sp>
+        <p:nvSpPr>
+          <p:cNvPr id="12" name="TextBox 11"/>
           <p:cNvSpPr txBox="1"/>
           <p:nvPr/>
         </p:nvSpPr>
         <p:spPr>
           <a:xfrm>
-            <a:off x="1828800" y="4663440"/>
-            <a:ext cx="8503920" cy="914400"/>
+            <a:off x="2255824" y="1847088"/>
+            <a:ext cx="347472" cy="329184"/>
           </a:xfrm>
           <a:prstGeom prst="rect">
             <a:avLst/>
@@ -5957,13 +5767,294 @@
               </a:spcAft>
             </a:pPr>
             <a:r>
-              <a:rPr sz="2200" b="0">
+              <a:rPr sz="1400" b="1">
                 <a:solidFill>
-                  <a:srgbClr val="E65096"/>
+                  <a:srgbClr val="FFFFFF"/>
                 </a:solidFill>
                 <a:latin typeface="Microsoft YaHei"/>
               </a:rPr>
-              <a:t>续写童话 / 改写寓言 / 十年后的我 / 课本剧</a:t>
+              <a:t>1</a:t>
+            </a:r>
+          </a:p>
+        </p:txBody>
+      </p:sp>
+      <p:sp>
+        <p:nvSpPr>
+          <p:cNvPr id="13" name="TextBox 12"/>
+          <p:cNvSpPr txBox="1"/>
+          <p:nvPr/>
+        </p:nvSpPr>
+        <p:spPr>
+          <a:xfrm>
+            <a:off x="2713024" y="1810512"/>
+            <a:ext cx="7863840" cy="457200"/>
+          </a:xfrm>
+          <a:prstGeom prst="rect">
+            <a:avLst/>
+          </a:prstGeom>
+          <a:noFill/>
+        </p:spPr>
+        <p:txBody>
+          <a:bodyPr wrap="none">
+            <a:spAutoFit/>
+          </a:bodyPr>
+          <a:lstStyle/>
+          <a:p>
+            <a:pPr algn="l">
+              <a:spcAft>
+                <a:spcPts val="1000"/>
+              </a:spcAft>
+            </a:pPr>
+            <a:r>
+              <a:rPr sz="2400" b="0">
+                <a:solidFill>
+                  <a:srgbClr val="46325A"/>
+                </a:solidFill>
+                <a:latin typeface="Microsoft YaHei"/>
+              </a:rPr>
+              <a:t>布展：说明卡+创作作品，附「请看我如何从文本出发」</a:t>
+            </a:r>
+          </a:p>
+        </p:txBody>
+      </p:sp>
+      <p:sp>
+        <p:nvSpPr>
+          <p:cNvPr id="14" name="Oval 13"/>
+          <p:cNvSpPr/>
+          <p:nvPr/>
+        </p:nvSpPr>
+        <p:spPr>
+          <a:xfrm>
+            <a:off x="2255824" y="2395728"/>
+            <a:ext cx="347472" cy="347472"/>
+          </a:xfrm>
+          <a:prstGeom prst="ellipse">
+            <a:avLst/>
+          </a:prstGeom>
+          <a:solidFill>
+            <a:srgbClr val="E65096"/>
+          </a:solidFill>
+          <a:ln>
+            <a:noFill/>
+          </a:ln>
+        </p:spPr>
+        <p:style>
+          <a:lnRef idx="1">
+            <a:schemeClr val="accent1"/>
+          </a:lnRef>
+          <a:fillRef idx="3">
+            <a:schemeClr val="accent1"/>
+          </a:fillRef>
+          <a:effectRef idx="2">
+            <a:schemeClr val="accent1"/>
+          </a:effectRef>
+          <a:fontRef idx="minor">
+            <a:schemeClr val="lt1"/>
+          </a:fontRef>
+        </p:style>
+        <p:txBody>
+          <a:bodyPr rtlCol="0" anchor="ctr"/>
+          <a:lstStyle/>
+          <a:p>
+            <a:pPr algn="ctr"/>
+          </a:p>
+        </p:txBody>
+      </p:sp>
+      <p:sp>
+        <p:nvSpPr>
+          <p:cNvPr id="15" name="TextBox 14"/>
+          <p:cNvSpPr txBox="1"/>
+          <p:nvPr/>
+        </p:nvSpPr>
+        <p:spPr>
+          <a:xfrm>
+            <a:off x="2255824" y="2414016"/>
+            <a:ext cx="347472" cy="329184"/>
+          </a:xfrm>
+          <a:prstGeom prst="rect">
+            <a:avLst/>
+          </a:prstGeom>
+          <a:noFill/>
+        </p:spPr>
+        <p:txBody>
+          <a:bodyPr wrap="none">
+            <a:spAutoFit/>
+          </a:bodyPr>
+          <a:lstStyle/>
+          <a:p>
+            <a:pPr algn="ctr">
+              <a:spcAft>
+                <a:spcPts val="1000"/>
+              </a:spcAft>
+            </a:pPr>
+            <a:r>
+              <a:rPr sz="1400" b="1">
+                <a:solidFill>
+                  <a:srgbClr val="FFFFFF"/>
+                </a:solidFill>
+                <a:latin typeface="Microsoft YaHei"/>
+              </a:rPr>
+              <a:t>2</a:t>
+            </a:r>
+          </a:p>
+        </p:txBody>
+      </p:sp>
+      <p:sp>
+        <p:nvSpPr>
+          <p:cNvPr id="16" name="TextBox 15"/>
+          <p:cNvSpPr txBox="1"/>
+          <p:nvPr/>
+        </p:nvSpPr>
+        <p:spPr>
+          <a:xfrm>
+            <a:off x="2713024" y="2377440"/>
+            <a:ext cx="7863840" cy="457200"/>
+          </a:xfrm>
+          <a:prstGeom prst="rect">
+            <a:avLst/>
+          </a:prstGeom>
+          <a:noFill/>
+        </p:spPr>
+        <p:txBody>
+          <a:bodyPr wrap="none">
+            <a:spAutoFit/>
+          </a:bodyPr>
+          <a:lstStyle/>
+          <a:p>
+            <a:pPr algn="l">
+              <a:spcAft>
+                <a:spcPts val="1000"/>
+              </a:spcAft>
+            </a:pPr>
+            <a:r>
+              <a:rPr sz="2400" b="0">
+                <a:solidFill>
+                  <a:srgbClr val="46325A"/>
+                </a:solidFill>
+                <a:latin typeface="Microsoft YaHei"/>
+              </a:rPr>
+              <a:t>讲解：30秒依据+60秒亮点+30秒思考</a:t>
+            </a:r>
+          </a:p>
+        </p:txBody>
+      </p:sp>
+      <p:sp>
+        <p:nvSpPr>
+          <p:cNvPr id="17" name="Oval 16"/>
+          <p:cNvSpPr/>
+          <p:nvPr/>
+        </p:nvSpPr>
+        <p:spPr>
+          <a:xfrm>
+            <a:off x="2255824" y="2962656"/>
+            <a:ext cx="347472" cy="347472"/>
+          </a:xfrm>
+          <a:prstGeom prst="ellipse">
+            <a:avLst/>
+          </a:prstGeom>
+          <a:solidFill>
+            <a:srgbClr val="E65096"/>
+          </a:solidFill>
+          <a:ln>
+            <a:noFill/>
+          </a:ln>
+        </p:spPr>
+        <p:style>
+          <a:lnRef idx="1">
+            <a:schemeClr val="accent1"/>
+          </a:lnRef>
+          <a:fillRef idx="3">
+            <a:schemeClr val="accent1"/>
+          </a:fillRef>
+          <a:effectRef idx="2">
+            <a:schemeClr val="accent1"/>
+          </a:effectRef>
+          <a:fontRef idx="minor">
+            <a:schemeClr val="lt1"/>
+          </a:fontRef>
+        </p:style>
+        <p:txBody>
+          <a:bodyPr rtlCol="0" anchor="ctr"/>
+          <a:lstStyle/>
+          <a:p>
+            <a:pPr algn="ctr"/>
+          </a:p>
+        </p:txBody>
+      </p:sp>
+      <p:sp>
+        <p:nvSpPr>
+          <p:cNvPr id="18" name="TextBox 17"/>
+          <p:cNvSpPr txBox="1"/>
+          <p:nvPr/>
+        </p:nvSpPr>
+        <p:spPr>
+          <a:xfrm>
+            <a:off x="2255824" y="2980944"/>
+            <a:ext cx="347472" cy="329184"/>
+          </a:xfrm>
+          <a:prstGeom prst="rect">
+            <a:avLst/>
+          </a:prstGeom>
+          <a:noFill/>
+        </p:spPr>
+        <p:txBody>
+          <a:bodyPr wrap="none">
+            <a:spAutoFit/>
+          </a:bodyPr>
+          <a:lstStyle/>
+          <a:p>
+            <a:pPr algn="ctr">
+              <a:spcAft>
+                <a:spcPts val="1000"/>
+              </a:spcAft>
+            </a:pPr>
+            <a:r>
+              <a:rPr sz="1400" b="1">
+                <a:solidFill>
+                  <a:srgbClr val="FFFFFF"/>
+                </a:solidFill>
+                <a:latin typeface="Microsoft YaHei"/>
+              </a:rPr>
+              <a:t>3</a:t>
+            </a:r>
+          </a:p>
+        </p:txBody>
+      </p:sp>
+      <p:sp>
+        <p:nvSpPr>
+          <p:cNvPr id="19" name="TextBox 18"/>
+          <p:cNvSpPr txBox="1"/>
+          <p:nvPr/>
+        </p:nvSpPr>
+        <p:spPr>
+          <a:xfrm>
+            <a:off x="2713024" y="2944368"/>
+            <a:ext cx="7863840" cy="457200"/>
+          </a:xfrm>
+          <a:prstGeom prst="rect">
+            <a:avLst/>
+          </a:prstGeom>
+          <a:noFill/>
+        </p:spPr>
+        <p:txBody>
+          <a:bodyPr wrap="none">
+            <a:spAutoFit/>
+          </a:bodyPr>
+          <a:lstStyle/>
+          <a:p>
+            <a:pPr algn="l">
+              <a:spcAft>
+                <a:spcPts val="1000"/>
+              </a:spcAft>
+            </a:pPr>
+            <a:r>
+              <a:rPr sz="2400" b="0">
+                <a:solidFill>
+                  <a:srgbClr val="46325A"/>
+                </a:solidFill>
+                <a:latin typeface="Microsoft YaHei"/>
+              </a:rPr>
+              <a:t>评价：投「发现卡」——最有依据 / 最有新意</a:t>
             </a:r>
           </a:p>
         </p:txBody>
@@ -6178,7 +6269,7 @@
                 </a:solidFill>
                 <a:latin typeface="Microsoft YaHei"/>
               </a:rPr>
-              <a:t>成果展示</a:t>
+              <a:t>总结笔记</a:t>
             </a:r>
           </a:p>
         </p:txBody>
@@ -6211,13 +6302,13 @@
               </a:spcAft>
             </a:pPr>
             <a:r>
-              <a:rPr sz="3600" b="1">
+              <a:rPr sz="3400" b="1">
                 <a:solidFill>
                   <a:srgbClr val="E65096"/>
                 </a:solidFill>
                 <a:latin typeface="Microsoft YaHei"/>
               </a:rPr>
-              <a:t>第十二课时</a:t>
+              <a:t>单元回顾</a:t>
             </a:r>
           </a:p>
         </p:txBody>
@@ -6273,8 +6364,8 @@
         </p:nvSpPr>
         <p:spPr>
           <a:xfrm>
-            <a:off x="1295704" y="1645920"/>
-            <a:ext cx="9601200" cy="2240280"/>
+            <a:off x="1158544" y="1645920"/>
+            <a:ext cx="9875520" cy="2953512"/>
           </a:xfrm>
           <a:prstGeom prst="roundRect">
             <a:avLst/>
@@ -6312,57 +6403,14 @@
       </p:sp>
       <p:sp>
         <p:nvSpPr>
-          <p:cNvPr id="11" name="Oval 10"/>
-          <p:cNvSpPr/>
-          <p:nvPr/>
-        </p:nvSpPr>
-        <p:spPr>
-          <a:xfrm>
-            <a:off x="2255824" y="1828800"/>
-            <a:ext cx="384048" cy="384048"/>
-          </a:xfrm>
-          <a:prstGeom prst="ellipse">
-            <a:avLst/>
-          </a:prstGeom>
-          <a:solidFill>
-            <a:srgbClr val="E65096"/>
-          </a:solidFill>
-          <a:ln>
-            <a:noFill/>
-          </a:ln>
-        </p:spPr>
-        <p:style>
-          <a:lnRef idx="1">
-            <a:schemeClr val="accent1"/>
-          </a:lnRef>
-          <a:fillRef idx="3">
-            <a:schemeClr val="accent1"/>
-          </a:fillRef>
-          <a:effectRef idx="2">
-            <a:schemeClr val="accent1"/>
-          </a:effectRef>
-          <a:fontRef idx="minor">
-            <a:schemeClr val="lt1"/>
-          </a:fontRef>
-        </p:style>
-        <p:txBody>
-          <a:bodyPr rtlCol="0" anchor="ctr"/>
-          <a:lstStyle/>
-          <a:p>
-            <a:pPr algn="ctr"/>
-          </a:p>
-        </p:txBody>
-      </p:sp>
-      <p:sp>
-        <p:nvSpPr>
-          <p:cNvPr id="12" name="TextBox 11"/>
+          <p:cNvPr id="11" name="TextBox 10"/>
           <p:cNvSpPr txBox="1"/>
           <p:nvPr/>
         </p:nvSpPr>
         <p:spPr>
           <a:xfrm>
-            <a:off x="2255824" y="1847088"/>
-            <a:ext cx="384048" cy="365760"/>
+            <a:off x="1234440" y="1783080"/>
+            <a:ext cx="2377440" cy="502920"/>
           </a:xfrm>
           <a:prstGeom prst="rect">
             <a:avLst/>
@@ -6375,33 +6423,33 @@
           </a:bodyPr>
           <a:lstStyle/>
           <a:p>
-            <a:pPr algn="ctr">
+            <a:pPr algn="r">
               <a:spcAft>
                 <a:spcPts val="1000"/>
               </a:spcAft>
             </a:pPr>
             <a:r>
-              <a:rPr sz="1600" b="1">
+              <a:rPr sz="2200" b="1">
                 <a:solidFill>
-                  <a:srgbClr val="FFFFFF"/>
+                  <a:srgbClr val="E65096"/>
                 </a:solidFill>
                 <a:latin typeface="Microsoft YaHei"/>
               </a:rPr>
-              <a:t>1</a:t>
-            </a:r>
-          </a:p>
-        </p:txBody>
-      </p:sp>
-      <p:sp>
-        <p:nvSpPr>
-          <p:cNvPr id="13" name="TextBox 12"/>
+              <a:t>母题链</a:t>
+            </a:r>
+          </a:p>
+        </p:txBody>
+      </p:sp>
+      <p:sp>
+        <p:nvSpPr>
+          <p:cNvPr id="12" name="TextBox 11"/>
           <p:cNvSpPr txBox="1"/>
           <p:nvPr/>
         </p:nvSpPr>
         <p:spPr>
           <a:xfrm>
-            <a:off x="2758744" y="1810512"/>
-            <a:ext cx="7772400" cy="502920"/>
+            <a:off x="3749039" y="1783080"/>
+            <a:ext cx="7589520" cy="594360"/>
           </a:xfrm>
           <a:prstGeom prst="rect">
             <a:avLst/>
@@ -6420,70 +6468,27 @@
               </a:spcAft>
             </a:pPr>
             <a:r>
-              <a:rPr sz="2400" b="0">
+              <a:rPr sz="2200" b="0">
                 <a:solidFill>
                   <a:srgbClr val="46325A"/>
                 </a:solidFill>
                 <a:latin typeface="Microsoft YaHei"/>
               </a:rPr>
-              <a:t>布展：说明卡 + 创作作品，附一句「请看我如何从文本出发」</a:t>
-            </a:r>
-          </a:p>
-        </p:txBody>
-      </p:sp>
-      <p:sp>
-        <p:nvSpPr>
-          <p:cNvPr id="14" name="Oval 13"/>
-          <p:cNvSpPr/>
-          <p:nvPr/>
-        </p:nvSpPr>
-        <p:spPr>
-          <a:xfrm>
-            <a:off x="2255824" y="2395728"/>
-            <a:ext cx="384048" cy="384048"/>
-          </a:xfrm>
-          <a:prstGeom prst="ellipse">
-            <a:avLst/>
-          </a:prstGeom>
-          <a:solidFill>
-            <a:srgbClr val="E65096"/>
-          </a:solidFill>
-          <a:ln>
-            <a:noFill/>
-          </a:ln>
-        </p:spPr>
-        <p:style>
-          <a:lnRef idx="1">
-            <a:schemeClr val="accent1"/>
-          </a:lnRef>
-          <a:fillRef idx="3">
-            <a:schemeClr val="accent1"/>
-          </a:fillRef>
-          <a:effectRef idx="2">
-            <a:schemeClr val="accent1"/>
-          </a:effectRef>
-          <a:fontRef idx="minor">
-            <a:schemeClr val="lt1"/>
-          </a:fontRef>
-        </p:style>
-        <p:txBody>
-          <a:bodyPr rtlCol="0" anchor="ctr"/>
-          <a:lstStyle/>
-          <a:p>
-            <a:pPr algn="ctr"/>
-          </a:p>
-        </p:txBody>
-      </p:sp>
-      <p:sp>
-        <p:nvSpPr>
-          <p:cNvPr id="15" name="TextBox 14"/>
+              <a:t>自由→真实→创造→智慧</a:t>
+            </a:r>
+          </a:p>
+        </p:txBody>
+      </p:sp>
+      <p:sp>
+        <p:nvSpPr>
+          <p:cNvPr id="13" name="TextBox 12"/>
           <p:cNvSpPr txBox="1"/>
           <p:nvPr/>
         </p:nvSpPr>
         <p:spPr>
           <a:xfrm>
-            <a:off x="2255824" y="2414016"/>
-            <a:ext cx="384048" cy="365760"/>
+            <a:off x="1234440" y="2441448"/>
+            <a:ext cx="2377440" cy="502920"/>
           </a:xfrm>
           <a:prstGeom prst="rect">
             <a:avLst/>
@@ -6496,33 +6501,33 @@
           </a:bodyPr>
           <a:lstStyle/>
           <a:p>
-            <a:pPr algn="ctr">
+            <a:pPr algn="r">
               <a:spcAft>
                 <a:spcPts val="1000"/>
               </a:spcAft>
             </a:pPr>
             <a:r>
-              <a:rPr sz="1600" b="1">
+              <a:rPr sz="2200" b="1">
                 <a:solidFill>
-                  <a:srgbClr val="FFFFFF"/>
+                  <a:srgbClr val="E65096"/>
                 </a:solidFill>
                 <a:latin typeface="Microsoft YaHei"/>
               </a:rPr>
-              <a:t>2</a:t>
-            </a:r>
-          </a:p>
-        </p:txBody>
-      </p:sp>
-      <p:sp>
-        <p:nvSpPr>
-          <p:cNvPr id="16" name="TextBox 15"/>
+              <a:t>核心领悟</a:t>
+            </a:r>
+          </a:p>
+        </p:txBody>
+      </p:sp>
+      <p:sp>
+        <p:nvSpPr>
+          <p:cNvPr id="14" name="TextBox 13"/>
           <p:cNvSpPr txBox="1"/>
           <p:nvPr/>
         </p:nvSpPr>
         <p:spPr>
           <a:xfrm>
-            <a:off x="2758744" y="2377440"/>
-            <a:ext cx="7772400" cy="502920"/>
+            <a:off x="3749039" y="2441448"/>
+            <a:ext cx="7589520" cy="594360"/>
           </a:xfrm>
           <a:prstGeom prst="rect">
             <a:avLst/>
@@ -6541,70 +6546,27 @@
               </a:spcAft>
             </a:pPr>
             <a:r>
-              <a:rPr sz="2400" b="0">
+              <a:rPr sz="2200" b="0">
                 <a:solidFill>
                   <a:srgbClr val="46325A"/>
                 </a:solidFill>
                 <a:latin typeface="Microsoft YaHei"/>
               </a:rPr>
-              <a:t>讲解：30秒依据 + 60秒亮点 + 30秒思考</a:t>
-            </a:r>
-          </a:p>
-        </p:txBody>
-      </p:sp>
-      <p:sp>
-        <p:nvSpPr>
-          <p:cNvPr id="17" name="Oval 16"/>
-          <p:cNvSpPr/>
-          <p:nvPr/>
-        </p:nvSpPr>
-        <p:spPr>
-          <a:xfrm>
-            <a:off x="2255824" y="2962656"/>
-            <a:ext cx="384048" cy="384048"/>
-          </a:xfrm>
-          <a:prstGeom prst="ellipse">
-            <a:avLst/>
-          </a:prstGeom>
-          <a:solidFill>
-            <a:srgbClr val="E65096"/>
-          </a:solidFill>
-          <a:ln>
-            <a:noFill/>
-          </a:ln>
-        </p:spPr>
-        <p:style>
-          <a:lnRef idx="1">
-            <a:schemeClr val="accent1"/>
-          </a:lnRef>
-          <a:fillRef idx="3">
-            <a:schemeClr val="accent1"/>
-          </a:fillRef>
-          <a:effectRef idx="2">
-            <a:schemeClr val="accent1"/>
-          </a:effectRef>
-          <a:fontRef idx="minor">
-            <a:schemeClr val="lt1"/>
-          </a:fontRef>
-        </p:style>
-        <p:txBody>
-          <a:bodyPr rtlCol="0" anchor="ctr"/>
-          <a:lstStyle/>
-          <a:p>
-            <a:pPr algn="ctr"/>
-          </a:p>
-        </p:txBody>
-      </p:sp>
-      <p:sp>
-        <p:nvSpPr>
-          <p:cNvPr id="18" name="TextBox 17"/>
+              <a:t>想象必须扎根于真实，飞得再高也要落回地面</a:t>
+            </a:r>
+          </a:p>
+        </p:txBody>
+      </p:sp>
+      <p:sp>
+        <p:nvSpPr>
+          <p:cNvPr id="15" name="TextBox 14"/>
           <p:cNvSpPr txBox="1"/>
           <p:nvPr/>
         </p:nvSpPr>
         <p:spPr>
           <a:xfrm>
-            <a:off x="2255824" y="2980944"/>
-            <a:ext cx="384048" cy="365760"/>
+            <a:off x="1234440" y="3099815"/>
+            <a:ext cx="2377440" cy="502920"/>
           </a:xfrm>
           <a:prstGeom prst="rect">
             <a:avLst/>
@@ -6617,1595 +6579,13 @@
           </a:bodyPr>
           <a:lstStyle/>
           <a:p>
-            <a:pPr algn="ctr">
+            <a:pPr algn="r">
               <a:spcAft>
                 <a:spcPts val="1000"/>
               </a:spcAft>
             </a:pPr>
             <a:r>
-              <a:rPr sz="1600" b="1">
-                <a:solidFill>
-                  <a:srgbClr val="FFFFFF"/>
-                </a:solidFill>
-                <a:latin typeface="Microsoft YaHei"/>
-              </a:rPr>
-              <a:t>3</a:t>
-            </a:r>
-          </a:p>
-        </p:txBody>
-      </p:sp>
-      <p:sp>
-        <p:nvSpPr>
-          <p:cNvPr id="19" name="TextBox 18"/>
-          <p:cNvSpPr txBox="1"/>
-          <p:nvPr/>
-        </p:nvSpPr>
-        <p:spPr>
-          <a:xfrm>
-            <a:off x="2758744" y="2944368"/>
-            <a:ext cx="7772400" cy="502920"/>
-          </a:xfrm>
-          <a:prstGeom prst="rect">
-            <a:avLst/>
-          </a:prstGeom>
-          <a:noFill/>
-        </p:spPr>
-        <p:txBody>
-          <a:bodyPr wrap="none">
-            <a:spAutoFit/>
-          </a:bodyPr>
-          <a:lstStyle/>
-          <a:p>
-            <a:pPr algn="l">
-              <a:spcAft>
-                <a:spcPts val="1000"/>
-              </a:spcAft>
-            </a:pPr>
-            <a:r>
-              <a:rPr sz="2400" b="0">
-                <a:solidFill>
-                  <a:srgbClr val="46325A"/>
-                </a:solidFill>
-                <a:latin typeface="Microsoft YaHei"/>
-              </a:rPr>
-              <a:t>参观者投「发现卡」并写理由</a:t>
-            </a:r>
-          </a:p>
-        </p:txBody>
-      </p:sp>
-    </p:spTree>
-  </p:cSld>
-  <p:clrMapOvr>
-    <a:masterClrMapping/>
-  </p:clrMapOvr>
-</p:sld>
-</file>
-
-<file path=ppt/slides/slide7.xml><?xml version="1.0" encoding="utf-8"?>
-<p:sld xmlns:a="http://schemas.openxmlformats.org/drawingml/2006/main" xmlns:p="http://schemas.openxmlformats.org/presentationml/2006/main" xmlns:r="http://schemas.openxmlformats.org/officeDocument/2006/relationships">
-  <p:cSld>
-    <p:spTree>
-      <p:nvGrpSpPr>
-        <p:cNvPr id="1" name=""/>
-        <p:cNvGrpSpPr/>
-        <p:nvPr/>
-      </p:nvGrpSpPr>
-      <p:grpSpPr/>
-      <p:pic>
-        <p:nvPicPr>
-          <p:cNvPr id="2" name="Picture 1" descr="bg_final.png"/>
-          <p:cNvPicPr>
-            <a:picLocks noChangeAspect="1"/>
-          </p:cNvPicPr>
-          <p:nvPr/>
-        </p:nvPicPr>
-        <p:blipFill>
-          <a:blip r:embed="rId2"/>
-          <a:stretch>
-            <a:fillRect/>
-          </a:stretch>
-        </p:blipFill>
-        <p:spPr>
-          <a:xfrm>
-            <a:off x="0" y="0"/>
-            <a:ext cx="12191695" cy="6858000"/>
-          </a:xfrm>
-          <a:prstGeom prst="rect">
-            <a:avLst/>
-          </a:prstGeom>
-        </p:spPr>
-      </p:pic>
-      <p:sp>
-        <p:nvSpPr>
-          <p:cNvPr id="3" name="Rectangle 2"/>
-          <p:cNvSpPr/>
-          <p:nvPr/>
-        </p:nvSpPr>
-        <p:spPr>
-          <a:xfrm>
-            <a:off x="292608" y="274320"/>
-            <a:ext cx="11594592" cy="6300216"/>
-          </a:xfrm>
-          <a:prstGeom prst="rect">
-            <a:avLst/>
-          </a:prstGeom>
-          <a:noFill/>
-          <a:ln w="31750">
-            <a:solidFill>
-              <a:srgbClr val="B464B4"/>
-            </a:solidFill>
-          </a:ln>
-        </p:spPr>
-        <p:style>
-          <a:lnRef idx="1">
-            <a:schemeClr val="accent1"/>
-          </a:lnRef>
-          <a:fillRef idx="3">
-            <a:schemeClr val="accent1"/>
-          </a:fillRef>
-          <a:effectRef idx="2">
-            <a:schemeClr val="accent1"/>
-          </a:effectRef>
-          <a:fontRef idx="minor">
-            <a:schemeClr val="lt1"/>
-          </a:fontRef>
-        </p:style>
-        <p:txBody>
-          <a:bodyPr rtlCol="0" anchor="ctr"/>
-          <a:lstStyle/>
-          <a:p>
-            <a:pPr algn="ctr"/>
-          </a:p>
-        </p:txBody>
-      </p:sp>
-      <p:pic>
-        <p:nvPicPr>
-          <p:cNvPr id="4" name="Picture 3" descr="corner_final_tl.png"/>
-          <p:cNvPicPr>
-            <a:picLocks noChangeAspect="1"/>
-          </p:cNvPicPr>
-          <p:nvPr/>
-        </p:nvPicPr>
-        <p:blipFill>
-          <a:blip r:embed="rId3"/>
-          <a:stretch>
-            <a:fillRect/>
-          </a:stretch>
-        </p:blipFill>
-        <p:spPr>
-          <a:xfrm>
-            <a:off x="-45720" y="-45720"/>
-            <a:ext cx="2011680" cy="2011680"/>
-          </a:xfrm>
-          <a:prstGeom prst="rect">
-            <a:avLst/>
-          </a:prstGeom>
-        </p:spPr>
-      </p:pic>
-      <p:pic>
-        <p:nvPicPr>
-          <p:cNvPr id="5" name="Picture 4" descr="corner_final_tr.png"/>
-          <p:cNvPicPr>
-            <a:picLocks noChangeAspect="1"/>
-          </p:cNvPicPr>
-          <p:nvPr/>
-        </p:nvPicPr>
-        <p:blipFill>
-          <a:blip r:embed="rId4"/>
-          <a:stretch>
-            <a:fillRect/>
-          </a:stretch>
-        </p:blipFill>
-        <p:spPr>
-          <a:xfrm>
-            <a:off x="9875520" y="-45720"/>
-            <a:ext cx="2011680" cy="2011680"/>
-          </a:xfrm>
-          <a:prstGeom prst="rect">
-            <a:avLst/>
-          </a:prstGeom>
-        </p:spPr>
-      </p:pic>
-      <p:sp>
-        <p:nvSpPr>
-          <p:cNvPr id="6" name="Rounded Rectangle 5"/>
-          <p:cNvSpPr/>
-          <p:nvPr/>
-        </p:nvSpPr>
-        <p:spPr>
-          <a:xfrm>
-            <a:off x="4953304" y="502920"/>
-            <a:ext cx="2286000" cy="411480"/>
-          </a:xfrm>
-          <a:prstGeom prst="roundRect">
-            <a:avLst/>
-          </a:prstGeom>
-          <a:solidFill>
-            <a:srgbClr val="64C8DC"/>
-          </a:solidFill>
-          <a:ln>
-            <a:noFill/>
-          </a:ln>
-        </p:spPr>
-        <p:style>
-          <a:lnRef idx="1">
-            <a:schemeClr val="accent1"/>
-          </a:lnRef>
-          <a:fillRef idx="3">
-            <a:schemeClr val="accent1"/>
-          </a:fillRef>
-          <a:effectRef idx="2">
-            <a:schemeClr val="accent1"/>
-          </a:effectRef>
-          <a:fontRef idx="minor">
-            <a:schemeClr val="lt1"/>
-          </a:fontRef>
-        </p:style>
-        <p:txBody>
-          <a:bodyPr rtlCol="0" anchor="ctr"/>
-          <a:lstStyle/>
-          <a:p>
-            <a:pPr algn="ctr"/>
-          </a:p>
-        </p:txBody>
-      </p:sp>
-      <p:sp>
-        <p:nvSpPr>
-          <p:cNvPr id="7" name="TextBox 6"/>
-          <p:cNvSpPr txBox="1"/>
-          <p:nvPr/>
-        </p:nvSpPr>
-        <p:spPr>
-          <a:xfrm>
-            <a:off x="4953304" y="521208"/>
-            <a:ext cx="2286000" cy="384048"/>
-          </a:xfrm>
-          <a:prstGeom prst="rect">
-            <a:avLst/>
-          </a:prstGeom>
-          <a:noFill/>
-        </p:spPr>
-        <p:txBody>
-          <a:bodyPr wrap="none">
-            <a:spAutoFit/>
-          </a:bodyPr>
-          <a:lstStyle/>
-          <a:p>
-            <a:pPr algn="ctr">
-              <a:spcAft>
-                <a:spcPts val="1000"/>
-              </a:spcAft>
-            </a:pPr>
-            <a:r>
-              <a:rPr sz="1800" b="1">
-                <a:solidFill>
-                  <a:srgbClr val="46325A"/>
-                </a:solidFill>
-                <a:latin typeface="Microsoft YaHei"/>
-              </a:rPr>
-              <a:t>单元总结</a:t>
-            </a:r>
-          </a:p>
-        </p:txBody>
-      </p:sp>
-      <p:sp>
-        <p:nvSpPr>
-          <p:cNvPr id="8" name="TextBox 7"/>
-          <p:cNvSpPr txBox="1"/>
-          <p:nvPr/>
-        </p:nvSpPr>
-        <p:spPr>
-          <a:xfrm>
-            <a:off x="1371600" y="960120"/>
-            <a:ext cx="9418320" cy="822960"/>
-          </a:xfrm>
-          <a:prstGeom prst="rect">
-            <a:avLst/>
-          </a:prstGeom>
-          <a:noFill/>
-        </p:spPr>
-        <p:txBody>
-          <a:bodyPr wrap="square">
-            <a:spAutoFit/>
-          </a:bodyPr>
-          <a:lstStyle/>
-          <a:p>
-            <a:pPr algn="ctr">
-              <a:spcAft>
-                <a:spcPts val="1000"/>
-              </a:spcAft>
-            </a:pPr>
-            <a:r>
-              <a:rPr sz="3600" b="1">
-                <a:solidFill>
-                  <a:srgbClr val="E65096"/>
-                </a:solidFill>
-                <a:latin typeface="Microsoft YaHei"/>
-              </a:rPr>
-              <a:t>回望母题链</a:t>
-            </a:r>
-          </a:p>
-        </p:txBody>
-      </p:sp>
-      <p:sp>
-        <p:nvSpPr>
-          <p:cNvPr id="9" name="Rectangle 8"/>
-          <p:cNvSpPr/>
-          <p:nvPr/>
-        </p:nvSpPr>
-        <p:spPr>
-          <a:xfrm>
-            <a:off x="3200400" y="1600200"/>
-            <a:ext cx="5760720" cy="27432"/>
-          </a:xfrm>
-          <a:prstGeom prst="rect">
-            <a:avLst/>
-          </a:prstGeom>
-          <a:solidFill>
-            <a:srgbClr val="64C8DC"/>
-          </a:solidFill>
-          <a:ln>
-            <a:noFill/>
-          </a:ln>
-        </p:spPr>
-        <p:style>
-          <a:lnRef idx="1">
-            <a:schemeClr val="accent1"/>
-          </a:lnRef>
-          <a:fillRef idx="3">
-            <a:schemeClr val="accent1"/>
-          </a:fillRef>
-          <a:effectRef idx="2">
-            <a:schemeClr val="accent1"/>
-          </a:effectRef>
-          <a:fontRef idx="minor">
-            <a:schemeClr val="lt1"/>
-          </a:fontRef>
-        </p:style>
-        <p:txBody>
-          <a:bodyPr rtlCol="0" anchor="ctr"/>
-          <a:lstStyle/>
-          <a:p>
-            <a:pPr algn="ctr"/>
-          </a:p>
-        </p:txBody>
-      </p:sp>
-      <p:sp>
-        <p:nvSpPr>
-          <p:cNvPr id="10" name="Rounded Rectangle 9"/>
-          <p:cNvSpPr/>
-          <p:nvPr/>
-        </p:nvSpPr>
-        <p:spPr>
-          <a:xfrm>
-            <a:off x="1295704" y="1645920"/>
-            <a:ext cx="9601200" cy="2240280"/>
-          </a:xfrm>
-          <a:prstGeom prst="roundRect">
-            <a:avLst/>
-          </a:prstGeom>
-          <a:solidFill>
-            <a:srgbClr val="FFFAFF"/>
-          </a:solidFill>
-          <a:ln w="19050">
-            <a:solidFill>
-              <a:srgbClr val="64C8DC"/>
-            </a:solidFill>
-          </a:ln>
-        </p:spPr>
-        <p:style>
-          <a:lnRef idx="1">
-            <a:schemeClr val="accent1"/>
-          </a:lnRef>
-          <a:fillRef idx="3">
-            <a:schemeClr val="accent1"/>
-          </a:fillRef>
-          <a:effectRef idx="2">
-            <a:schemeClr val="accent1"/>
-          </a:effectRef>
-          <a:fontRef idx="minor">
-            <a:schemeClr val="lt1"/>
-          </a:fontRef>
-        </p:style>
-        <p:txBody>
-          <a:bodyPr rtlCol="0" anchor="ctr"/>
-          <a:lstStyle/>
-          <a:p>
-            <a:pPr algn="ctr"/>
-          </a:p>
-        </p:txBody>
-      </p:sp>
-      <p:sp>
-        <p:nvSpPr>
-          <p:cNvPr id="11" name="Oval 10"/>
-          <p:cNvSpPr/>
-          <p:nvPr/>
-        </p:nvSpPr>
-        <p:spPr>
-          <a:xfrm>
-            <a:off x="2255824" y="1828800"/>
-            <a:ext cx="384048" cy="384048"/>
-          </a:xfrm>
-          <a:prstGeom prst="ellipse">
-            <a:avLst/>
-          </a:prstGeom>
-          <a:solidFill>
-            <a:srgbClr val="E65096"/>
-          </a:solidFill>
-          <a:ln>
-            <a:noFill/>
-          </a:ln>
-        </p:spPr>
-        <p:style>
-          <a:lnRef idx="1">
-            <a:schemeClr val="accent1"/>
-          </a:lnRef>
-          <a:fillRef idx="3">
-            <a:schemeClr val="accent1"/>
-          </a:fillRef>
-          <a:effectRef idx="2">
-            <a:schemeClr val="accent1"/>
-          </a:effectRef>
-          <a:fontRef idx="minor">
-            <a:schemeClr val="lt1"/>
-          </a:fontRef>
-        </p:style>
-        <p:txBody>
-          <a:bodyPr rtlCol="0" anchor="ctr"/>
-          <a:lstStyle/>
-          <a:p>
-            <a:pPr algn="ctr"/>
-          </a:p>
-        </p:txBody>
-      </p:sp>
-      <p:sp>
-        <p:nvSpPr>
-          <p:cNvPr id="12" name="TextBox 11"/>
-          <p:cNvSpPr txBox="1"/>
-          <p:nvPr/>
-        </p:nvSpPr>
-        <p:spPr>
-          <a:xfrm>
-            <a:off x="2255824" y="1847088"/>
-            <a:ext cx="384048" cy="365760"/>
-          </a:xfrm>
-          <a:prstGeom prst="rect">
-            <a:avLst/>
-          </a:prstGeom>
-          <a:noFill/>
-        </p:spPr>
-        <p:txBody>
-          <a:bodyPr wrap="none">
-            <a:spAutoFit/>
-          </a:bodyPr>
-          <a:lstStyle/>
-          <a:p>
-            <a:pPr algn="ctr">
-              <a:spcAft>
-                <a:spcPts val="1000"/>
-              </a:spcAft>
-            </a:pPr>
-            <a:r>
-              <a:rPr sz="1600" b="1">
-                <a:solidFill>
-                  <a:srgbClr val="FFFFFF"/>
-                </a:solidFill>
-                <a:latin typeface="Microsoft YaHei"/>
-              </a:rPr>
-              <a:t>1</a:t>
-            </a:r>
-          </a:p>
-        </p:txBody>
-      </p:sp>
-      <p:sp>
-        <p:nvSpPr>
-          <p:cNvPr id="13" name="TextBox 12"/>
-          <p:cNvSpPr txBox="1"/>
-          <p:nvPr/>
-        </p:nvSpPr>
-        <p:spPr>
-          <a:xfrm>
-            <a:off x="2758744" y="1810512"/>
-            <a:ext cx="7772400" cy="502920"/>
-          </a:xfrm>
-          <a:prstGeom prst="rect">
-            <a:avLst/>
-          </a:prstGeom>
-          <a:noFill/>
-        </p:spPr>
-        <p:txBody>
-          <a:bodyPr wrap="none">
-            <a:spAutoFit/>
-          </a:bodyPr>
-          <a:lstStyle/>
-          <a:p>
-            <a:pPr algn="l">
-              <a:spcAft>
-                <a:spcPts val="1000"/>
-              </a:spcAft>
-            </a:pPr>
-            <a:r>
-              <a:rPr sz="2400" b="0">
-                <a:solidFill>
-                  <a:srgbClr val="46325A"/>
-                </a:solidFill>
-                <a:latin typeface="Microsoft YaHei"/>
-              </a:rPr>
-              <a:t>自由 → 真实 → 创造 → 智慧</a:t>
-            </a:r>
-          </a:p>
-        </p:txBody>
-      </p:sp>
-      <p:sp>
-        <p:nvSpPr>
-          <p:cNvPr id="14" name="Oval 13"/>
-          <p:cNvSpPr/>
-          <p:nvPr/>
-        </p:nvSpPr>
-        <p:spPr>
-          <a:xfrm>
-            <a:off x="2255824" y="2395728"/>
-            <a:ext cx="384048" cy="384048"/>
-          </a:xfrm>
-          <a:prstGeom prst="ellipse">
-            <a:avLst/>
-          </a:prstGeom>
-          <a:solidFill>
-            <a:srgbClr val="E65096"/>
-          </a:solidFill>
-          <a:ln>
-            <a:noFill/>
-          </a:ln>
-        </p:spPr>
-        <p:style>
-          <a:lnRef idx="1">
-            <a:schemeClr val="accent1"/>
-          </a:lnRef>
-          <a:fillRef idx="3">
-            <a:schemeClr val="accent1"/>
-          </a:fillRef>
-          <a:effectRef idx="2">
-            <a:schemeClr val="accent1"/>
-          </a:effectRef>
-          <a:fontRef idx="minor">
-            <a:schemeClr val="lt1"/>
-          </a:fontRef>
-        </p:style>
-        <p:txBody>
-          <a:bodyPr rtlCol="0" anchor="ctr"/>
-          <a:lstStyle/>
-          <a:p>
-            <a:pPr algn="ctr"/>
-          </a:p>
-        </p:txBody>
-      </p:sp>
-      <p:sp>
-        <p:nvSpPr>
-          <p:cNvPr id="15" name="TextBox 14"/>
-          <p:cNvSpPr txBox="1"/>
-          <p:nvPr/>
-        </p:nvSpPr>
-        <p:spPr>
-          <a:xfrm>
-            <a:off x="2255824" y="2414016"/>
-            <a:ext cx="384048" cy="365760"/>
-          </a:xfrm>
-          <a:prstGeom prst="rect">
-            <a:avLst/>
-          </a:prstGeom>
-          <a:noFill/>
-        </p:spPr>
-        <p:txBody>
-          <a:bodyPr wrap="none">
-            <a:spAutoFit/>
-          </a:bodyPr>
-          <a:lstStyle/>
-          <a:p>
-            <a:pPr algn="ctr">
-              <a:spcAft>
-                <a:spcPts val="1000"/>
-              </a:spcAft>
-            </a:pPr>
-            <a:r>
-              <a:rPr sz="1600" b="1">
-                <a:solidFill>
-                  <a:srgbClr val="FFFFFF"/>
-                </a:solidFill>
-                <a:latin typeface="Microsoft YaHei"/>
-              </a:rPr>
-              <a:t>2</a:t>
-            </a:r>
-          </a:p>
-        </p:txBody>
-      </p:sp>
-      <p:sp>
-        <p:nvSpPr>
-          <p:cNvPr id="16" name="TextBox 15"/>
-          <p:cNvSpPr txBox="1"/>
-          <p:nvPr/>
-        </p:nvSpPr>
-        <p:spPr>
-          <a:xfrm>
-            <a:off x="2758744" y="2377440"/>
-            <a:ext cx="7772400" cy="502920"/>
-          </a:xfrm>
-          <a:prstGeom prst="rect">
-            <a:avLst/>
-          </a:prstGeom>
-          <a:noFill/>
-        </p:spPr>
-        <p:txBody>
-          <a:bodyPr wrap="none">
-            <a:spAutoFit/>
-          </a:bodyPr>
-          <a:lstStyle/>
-          <a:p>
-            <a:pPr algn="l">
-              <a:spcAft>
-                <a:spcPts val="1000"/>
-              </a:spcAft>
-            </a:pPr>
-            <a:r>
-              <a:rPr sz="2400" b="0">
-                <a:solidFill>
-                  <a:srgbClr val="46325A"/>
-                </a:solidFill>
-                <a:latin typeface="Microsoft YaHei"/>
-              </a:rPr>
-              <a:t>成长就是在四者间不断寻找平衡</a:t>
-            </a:r>
-          </a:p>
-        </p:txBody>
-      </p:sp>
-      <p:sp>
-        <p:nvSpPr>
-          <p:cNvPr id="17" name="Oval 16"/>
-          <p:cNvSpPr/>
-          <p:nvPr/>
-        </p:nvSpPr>
-        <p:spPr>
-          <a:xfrm>
-            <a:off x="2255824" y="2962656"/>
-            <a:ext cx="384048" cy="384048"/>
-          </a:xfrm>
-          <a:prstGeom prst="ellipse">
-            <a:avLst/>
-          </a:prstGeom>
-          <a:solidFill>
-            <a:srgbClr val="E65096"/>
-          </a:solidFill>
-          <a:ln>
-            <a:noFill/>
-          </a:ln>
-        </p:spPr>
-        <p:style>
-          <a:lnRef idx="1">
-            <a:schemeClr val="accent1"/>
-          </a:lnRef>
-          <a:fillRef idx="3">
-            <a:schemeClr val="accent1"/>
-          </a:fillRef>
-          <a:effectRef idx="2">
-            <a:schemeClr val="accent1"/>
-          </a:effectRef>
-          <a:fontRef idx="minor">
-            <a:schemeClr val="lt1"/>
-          </a:fontRef>
-        </p:style>
-        <p:txBody>
-          <a:bodyPr rtlCol="0" anchor="ctr"/>
-          <a:lstStyle/>
-          <a:p>
-            <a:pPr algn="ctr"/>
-          </a:p>
-        </p:txBody>
-      </p:sp>
-      <p:sp>
-        <p:nvSpPr>
-          <p:cNvPr id="18" name="TextBox 17"/>
-          <p:cNvSpPr txBox="1"/>
-          <p:nvPr/>
-        </p:nvSpPr>
-        <p:spPr>
-          <a:xfrm>
-            <a:off x="2255824" y="2980944"/>
-            <a:ext cx="384048" cy="365760"/>
-          </a:xfrm>
-          <a:prstGeom prst="rect">
-            <a:avLst/>
-          </a:prstGeom>
-          <a:noFill/>
-        </p:spPr>
-        <p:txBody>
-          <a:bodyPr wrap="none">
-            <a:spAutoFit/>
-          </a:bodyPr>
-          <a:lstStyle/>
-          <a:p>
-            <a:pPr algn="ctr">
-              <a:spcAft>
-                <a:spcPts val="1000"/>
-              </a:spcAft>
-            </a:pPr>
-            <a:r>
-              <a:rPr sz="1600" b="1">
-                <a:solidFill>
-                  <a:srgbClr val="FFFFFF"/>
-                </a:solidFill>
-                <a:latin typeface="Microsoft YaHei"/>
-              </a:rPr>
-              <a:t>3</a:t>
-            </a:r>
-          </a:p>
-        </p:txBody>
-      </p:sp>
-      <p:sp>
-        <p:nvSpPr>
-          <p:cNvPr id="19" name="TextBox 18"/>
-          <p:cNvSpPr txBox="1"/>
-          <p:nvPr/>
-        </p:nvSpPr>
-        <p:spPr>
-          <a:xfrm>
-            <a:off x="2758744" y="2944368"/>
-            <a:ext cx="7772400" cy="502920"/>
-          </a:xfrm>
-          <a:prstGeom prst="rect">
-            <a:avLst/>
-          </a:prstGeom>
-          <a:noFill/>
-        </p:spPr>
-        <p:txBody>
-          <a:bodyPr wrap="none">
-            <a:spAutoFit/>
-          </a:bodyPr>
-          <a:lstStyle/>
-          <a:p>
-            <a:pPr algn="l">
-              <a:spcAft>
-                <a:spcPts val="1000"/>
-              </a:spcAft>
-            </a:pPr>
-            <a:r>
-              <a:rPr sz="2400" b="0">
-                <a:solidFill>
-                  <a:srgbClr val="46325A"/>
-                </a:solidFill>
-                <a:latin typeface="Microsoft YaHei"/>
-              </a:rPr>
-              <a:t>填写自评表，整理学习档案</a:t>
-            </a:r>
-          </a:p>
-        </p:txBody>
-      </p:sp>
-    </p:spTree>
-  </p:cSld>
-  <p:clrMapOvr>
-    <a:masterClrMapping/>
-  </p:clrMapOvr>
-</p:sld>
-</file>
-
-<file path=ppt/slides/slide8.xml><?xml version="1.0" encoding="utf-8"?>
-<p:sld xmlns:a="http://schemas.openxmlformats.org/drawingml/2006/main" xmlns:p="http://schemas.openxmlformats.org/presentationml/2006/main" xmlns:r="http://schemas.openxmlformats.org/officeDocument/2006/relationships">
-  <p:cSld>
-    <p:spTree>
-      <p:nvGrpSpPr>
-        <p:cNvPr id="1" name=""/>
-        <p:cNvGrpSpPr/>
-        <p:nvPr/>
-      </p:nvGrpSpPr>
-      <p:grpSpPr/>
-      <p:pic>
-        <p:nvPicPr>
-          <p:cNvPr id="2" name="Picture 1" descr="bg_final.png"/>
-          <p:cNvPicPr>
-            <a:picLocks noChangeAspect="1"/>
-          </p:cNvPicPr>
-          <p:nvPr/>
-        </p:nvPicPr>
-        <p:blipFill>
-          <a:blip r:embed="rId2"/>
-          <a:stretch>
-            <a:fillRect/>
-          </a:stretch>
-        </p:blipFill>
-        <p:spPr>
-          <a:xfrm>
-            <a:off x="0" y="0"/>
-            <a:ext cx="12191695" cy="6858000"/>
-          </a:xfrm>
-          <a:prstGeom prst="rect">
-            <a:avLst/>
-          </a:prstGeom>
-        </p:spPr>
-      </p:pic>
-      <p:sp>
-        <p:nvSpPr>
-          <p:cNvPr id="3" name="Rectangle 2"/>
-          <p:cNvSpPr/>
-          <p:nvPr/>
-        </p:nvSpPr>
-        <p:spPr>
-          <a:xfrm>
-            <a:off x="292608" y="274320"/>
-            <a:ext cx="11594592" cy="6300216"/>
-          </a:xfrm>
-          <a:prstGeom prst="rect">
-            <a:avLst/>
-          </a:prstGeom>
-          <a:noFill/>
-          <a:ln w="31750">
-            <a:solidFill>
-              <a:srgbClr val="B464B4"/>
-            </a:solidFill>
-          </a:ln>
-        </p:spPr>
-        <p:style>
-          <a:lnRef idx="1">
-            <a:schemeClr val="accent1"/>
-          </a:lnRef>
-          <a:fillRef idx="3">
-            <a:schemeClr val="accent1"/>
-          </a:fillRef>
-          <a:effectRef idx="2">
-            <a:schemeClr val="accent1"/>
-          </a:effectRef>
-          <a:fontRef idx="minor">
-            <a:schemeClr val="lt1"/>
-          </a:fontRef>
-        </p:style>
-        <p:txBody>
-          <a:bodyPr rtlCol="0" anchor="ctr"/>
-          <a:lstStyle/>
-          <a:p>
-            <a:pPr algn="ctr"/>
-          </a:p>
-        </p:txBody>
-      </p:sp>
-      <p:pic>
-        <p:nvPicPr>
-          <p:cNvPr id="4" name="Picture 3" descr="corner_final_tl.png"/>
-          <p:cNvPicPr>
-            <a:picLocks noChangeAspect="1"/>
-          </p:cNvPicPr>
-          <p:nvPr/>
-        </p:nvPicPr>
-        <p:blipFill>
-          <a:blip r:embed="rId3"/>
-          <a:stretch>
-            <a:fillRect/>
-          </a:stretch>
-        </p:blipFill>
-        <p:spPr>
-          <a:xfrm>
-            <a:off x="-45720" y="-45720"/>
-            <a:ext cx="2011680" cy="2011680"/>
-          </a:xfrm>
-          <a:prstGeom prst="rect">
-            <a:avLst/>
-          </a:prstGeom>
-        </p:spPr>
-      </p:pic>
-      <p:pic>
-        <p:nvPicPr>
-          <p:cNvPr id="5" name="Picture 4" descr="corner_final_tr.png"/>
-          <p:cNvPicPr>
-            <a:picLocks noChangeAspect="1"/>
-          </p:cNvPicPr>
-          <p:nvPr/>
-        </p:nvPicPr>
-        <p:blipFill>
-          <a:blip r:embed="rId4"/>
-          <a:stretch>
-            <a:fillRect/>
-          </a:stretch>
-        </p:blipFill>
-        <p:spPr>
-          <a:xfrm>
-            <a:off x="9875520" y="-45720"/>
-            <a:ext cx="2011680" cy="2011680"/>
-          </a:xfrm>
-          <a:prstGeom prst="rect">
-            <a:avLst/>
-          </a:prstGeom>
-        </p:spPr>
-      </p:pic>
-      <p:sp>
-        <p:nvSpPr>
-          <p:cNvPr id="6" name="Rounded Rectangle 5"/>
-          <p:cNvSpPr/>
-          <p:nvPr/>
-        </p:nvSpPr>
-        <p:spPr>
-          <a:xfrm>
-            <a:off x="4953304" y="502920"/>
-            <a:ext cx="2286000" cy="411480"/>
-          </a:xfrm>
-          <a:prstGeom prst="roundRect">
-            <a:avLst/>
-          </a:prstGeom>
-          <a:solidFill>
-            <a:srgbClr val="64C8DC"/>
-          </a:solidFill>
-          <a:ln>
-            <a:noFill/>
-          </a:ln>
-        </p:spPr>
-        <p:style>
-          <a:lnRef idx="1">
-            <a:schemeClr val="accent1"/>
-          </a:lnRef>
-          <a:fillRef idx="3">
-            <a:schemeClr val="accent1"/>
-          </a:fillRef>
-          <a:effectRef idx="2">
-            <a:schemeClr val="accent1"/>
-          </a:effectRef>
-          <a:fontRef idx="minor">
-            <a:schemeClr val="lt1"/>
-          </a:fontRef>
-        </p:style>
-        <p:txBody>
-          <a:bodyPr rtlCol="0" anchor="ctr"/>
-          <a:lstStyle/>
-          <a:p>
-            <a:pPr algn="ctr"/>
-          </a:p>
-        </p:txBody>
-      </p:sp>
-      <p:sp>
-        <p:nvSpPr>
-          <p:cNvPr id="7" name="TextBox 6"/>
-          <p:cNvSpPr txBox="1"/>
-          <p:nvPr/>
-        </p:nvSpPr>
-        <p:spPr>
-          <a:xfrm>
-            <a:off x="4953304" y="521208"/>
-            <a:ext cx="2286000" cy="384048"/>
-          </a:xfrm>
-          <a:prstGeom prst="rect">
-            <a:avLst/>
-          </a:prstGeom>
-          <a:noFill/>
-        </p:spPr>
-        <p:txBody>
-          <a:bodyPr wrap="none">
-            <a:spAutoFit/>
-          </a:bodyPr>
-          <a:lstStyle/>
-          <a:p>
-            <a:pPr algn="ctr">
-              <a:spcAft>
-                <a:spcPts val="1000"/>
-              </a:spcAft>
-            </a:pPr>
-            <a:r>
-              <a:rPr sz="1800" b="1">
-                <a:solidFill>
-                  <a:srgbClr val="46325A"/>
-                </a:solidFill>
-                <a:latin typeface="Microsoft YaHei"/>
-              </a:rPr>
-              <a:t>回顾收获</a:t>
-            </a:r>
-          </a:p>
-        </p:txBody>
-      </p:sp>
-      <p:sp>
-        <p:nvSpPr>
-          <p:cNvPr id="8" name="TextBox 7"/>
-          <p:cNvSpPr txBox="1"/>
-          <p:nvPr/>
-        </p:nvSpPr>
-        <p:spPr>
-          <a:xfrm>
-            <a:off x="1371600" y="960120"/>
-            <a:ext cx="9418320" cy="822960"/>
-          </a:xfrm>
-          <a:prstGeom prst="rect">
-            <a:avLst/>
-          </a:prstGeom>
-          <a:noFill/>
-        </p:spPr>
-        <p:txBody>
-          <a:bodyPr wrap="square">
-            <a:spAutoFit/>
-          </a:bodyPr>
-          <a:lstStyle/>
-          <a:p>
-            <a:pPr algn="ctr">
-              <a:spcAft>
-                <a:spcPts val="1000"/>
-              </a:spcAft>
-            </a:pPr>
-            <a:r>
-              <a:rPr sz="3600" b="1">
-                <a:solidFill>
-                  <a:srgbClr val="E65096"/>
-                </a:solidFill>
-                <a:latin typeface="Microsoft YaHei"/>
-              </a:rPr>
-              <a:t>课堂小结</a:t>
-            </a:r>
-          </a:p>
-        </p:txBody>
-      </p:sp>
-      <p:sp>
-        <p:nvSpPr>
-          <p:cNvPr id="9" name="Rectangle 8"/>
-          <p:cNvSpPr/>
-          <p:nvPr/>
-        </p:nvSpPr>
-        <p:spPr>
-          <a:xfrm>
-            <a:off x="3200400" y="1600200"/>
-            <a:ext cx="5760720" cy="27432"/>
-          </a:xfrm>
-          <a:prstGeom prst="rect">
-            <a:avLst/>
-          </a:prstGeom>
-          <a:solidFill>
-            <a:srgbClr val="64C8DC"/>
-          </a:solidFill>
-          <a:ln>
-            <a:noFill/>
-          </a:ln>
-        </p:spPr>
-        <p:style>
-          <a:lnRef idx="1">
-            <a:schemeClr val="accent1"/>
-          </a:lnRef>
-          <a:fillRef idx="3">
-            <a:schemeClr val="accent1"/>
-          </a:fillRef>
-          <a:effectRef idx="2">
-            <a:schemeClr val="accent1"/>
-          </a:effectRef>
-          <a:fontRef idx="minor">
-            <a:schemeClr val="lt1"/>
-          </a:fontRef>
-        </p:style>
-        <p:txBody>
-          <a:bodyPr rtlCol="0" anchor="ctr"/>
-          <a:lstStyle/>
-          <a:p>
-            <a:pPr algn="ctr"/>
-          </a:p>
-        </p:txBody>
-      </p:sp>
-      <p:sp>
-        <p:nvSpPr>
-          <p:cNvPr id="10" name="Rounded Rectangle 9"/>
-          <p:cNvSpPr/>
-          <p:nvPr/>
-        </p:nvSpPr>
-        <p:spPr>
-          <a:xfrm>
-            <a:off x="1295704" y="1645920"/>
-            <a:ext cx="9601200" cy="1645920"/>
-          </a:xfrm>
-          <a:prstGeom prst="roundRect">
-            <a:avLst/>
-          </a:prstGeom>
-          <a:solidFill>
-            <a:srgbClr val="FFFAFF"/>
-          </a:solidFill>
-          <a:ln w="19050">
-            <a:solidFill>
-              <a:srgbClr val="64C8DC"/>
-            </a:solidFill>
-          </a:ln>
-        </p:spPr>
-        <p:style>
-          <a:lnRef idx="1">
-            <a:schemeClr val="accent1"/>
-          </a:lnRef>
-          <a:fillRef idx="3">
-            <a:schemeClr val="accent1"/>
-          </a:fillRef>
-          <a:effectRef idx="2">
-            <a:schemeClr val="accent1"/>
-          </a:effectRef>
-          <a:fontRef idx="minor">
-            <a:schemeClr val="lt1"/>
-          </a:fontRef>
-        </p:style>
-        <p:txBody>
-          <a:bodyPr rtlCol="0" anchor="ctr"/>
-          <a:lstStyle/>
-          <a:p>
-            <a:pPr algn="ctr"/>
-          </a:p>
-        </p:txBody>
-      </p:sp>
-      <p:sp>
-        <p:nvSpPr>
-          <p:cNvPr id="11" name="Oval 10"/>
-          <p:cNvSpPr/>
-          <p:nvPr/>
-        </p:nvSpPr>
-        <p:spPr>
-          <a:xfrm>
-            <a:off x="2255824" y="1828800"/>
-            <a:ext cx="384048" cy="384048"/>
-          </a:xfrm>
-          <a:prstGeom prst="ellipse">
-            <a:avLst/>
-          </a:prstGeom>
-          <a:solidFill>
-            <a:srgbClr val="E65096"/>
-          </a:solidFill>
-          <a:ln>
-            <a:noFill/>
-          </a:ln>
-        </p:spPr>
-        <p:style>
-          <a:lnRef idx="1">
-            <a:schemeClr val="accent1"/>
-          </a:lnRef>
-          <a:fillRef idx="3">
-            <a:schemeClr val="accent1"/>
-          </a:fillRef>
-          <a:effectRef idx="2">
-            <a:schemeClr val="accent1"/>
-          </a:effectRef>
-          <a:fontRef idx="minor">
-            <a:schemeClr val="lt1"/>
-          </a:fontRef>
-        </p:style>
-        <p:txBody>
-          <a:bodyPr rtlCol="0" anchor="ctr"/>
-          <a:lstStyle/>
-          <a:p>
-            <a:pPr algn="ctr"/>
-          </a:p>
-        </p:txBody>
-      </p:sp>
-      <p:sp>
-        <p:nvSpPr>
-          <p:cNvPr id="12" name="TextBox 11"/>
-          <p:cNvSpPr txBox="1"/>
-          <p:nvPr/>
-        </p:nvSpPr>
-        <p:spPr>
-          <a:xfrm>
-            <a:off x="2255824" y="1847088"/>
-            <a:ext cx="384048" cy="365760"/>
-          </a:xfrm>
-          <a:prstGeom prst="rect">
-            <a:avLst/>
-          </a:prstGeom>
-          <a:noFill/>
-        </p:spPr>
-        <p:txBody>
-          <a:bodyPr wrap="none">
-            <a:spAutoFit/>
-          </a:bodyPr>
-          <a:lstStyle/>
-          <a:p>
-            <a:pPr algn="ctr">
-              <a:spcAft>
-                <a:spcPts val="1000"/>
-              </a:spcAft>
-            </a:pPr>
-            <a:r>
-              <a:rPr sz="1600" b="1">
-                <a:solidFill>
-                  <a:srgbClr val="FFFFFF"/>
-                </a:solidFill>
-                <a:latin typeface="Microsoft YaHei"/>
-              </a:rPr>
-              <a:t>1</a:t>
-            </a:r>
-          </a:p>
-        </p:txBody>
-      </p:sp>
-      <p:sp>
-        <p:nvSpPr>
-          <p:cNvPr id="13" name="TextBox 12"/>
-          <p:cNvSpPr txBox="1"/>
-          <p:nvPr/>
-        </p:nvSpPr>
-        <p:spPr>
-          <a:xfrm>
-            <a:off x="2758744" y="1810512"/>
-            <a:ext cx="7772400" cy="502920"/>
-          </a:xfrm>
-          <a:prstGeom prst="rect">
-            <a:avLst/>
-          </a:prstGeom>
-          <a:noFill/>
-        </p:spPr>
-        <p:txBody>
-          <a:bodyPr wrap="none">
-            <a:spAutoFit/>
-          </a:bodyPr>
-          <a:lstStyle/>
-          <a:p>
-            <a:pPr algn="l">
-              <a:spcAft>
-                <a:spcPts val="1000"/>
-              </a:spcAft>
-            </a:pPr>
-            <a:r>
-              <a:rPr sz="2400" b="0">
-                <a:solidFill>
-                  <a:srgbClr val="46325A"/>
-                </a:solidFill>
-                <a:latin typeface="Microsoft YaHei"/>
-              </a:rPr>
-              <a:t>想象既是阅读能力，也是表达能力</a:t>
-            </a:r>
-          </a:p>
-        </p:txBody>
-      </p:sp>
-      <p:sp>
-        <p:nvSpPr>
-          <p:cNvPr id="14" name="Oval 13"/>
-          <p:cNvSpPr/>
-          <p:nvPr/>
-        </p:nvSpPr>
-        <p:spPr>
-          <a:xfrm>
-            <a:off x="2255824" y="2395728"/>
-            <a:ext cx="384048" cy="384048"/>
-          </a:xfrm>
-          <a:prstGeom prst="ellipse">
-            <a:avLst/>
-          </a:prstGeom>
-          <a:solidFill>
-            <a:srgbClr val="E65096"/>
-          </a:solidFill>
-          <a:ln>
-            <a:noFill/>
-          </a:ln>
-        </p:spPr>
-        <p:style>
-          <a:lnRef idx="1">
-            <a:schemeClr val="accent1"/>
-          </a:lnRef>
-          <a:fillRef idx="3">
-            <a:schemeClr val="accent1"/>
-          </a:fillRef>
-          <a:effectRef idx="2">
-            <a:schemeClr val="accent1"/>
-          </a:effectRef>
-          <a:fontRef idx="minor">
-            <a:schemeClr val="lt1"/>
-          </a:fontRef>
-        </p:style>
-        <p:txBody>
-          <a:bodyPr rtlCol="0" anchor="ctr"/>
-          <a:lstStyle/>
-          <a:p>
-            <a:pPr algn="ctr"/>
-          </a:p>
-        </p:txBody>
-      </p:sp>
-      <p:sp>
-        <p:nvSpPr>
-          <p:cNvPr id="15" name="TextBox 14"/>
-          <p:cNvSpPr txBox="1"/>
-          <p:nvPr/>
-        </p:nvSpPr>
-        <p:spPr>
-          <a:xfrm>
-            <a:off x="2255824" y="2414016"/>
-            <a:ext cx="384048" cy="365760"/>
-          </a:xfrm>
-          <a:prstGeom prst="rect">
-            <a:avLst/>
-          </a:prstGeom>
-          <a:noFill/>
-        </p:spPr>
-        <p:txBody>
-          <a:bodyPr wrap="none">
-            <a:spAutoFit/>
-          </a:bodyPr>
-          <a:lstStyle/>
-          <a:p>
-            <a:pPr algn="ctr">
-              <a:spcAft>
-                <a:spcPts val="1000"/>
-              </a:spcAft>
-            </a:pPr>
-            <a:r>
-              <a:rPr sz="1600" b="1">
-                <a:solidFill>
-                  <a:srgbClr val="FFFFFF"/>
-                </a:solidFill>
-                <a:latin typeface="Microsoft YaHei"/>
-              </a:rPr>
-              <a:t>2</a:t>
-            </a:r>
-          </a:p>
-        </p:txBody>
-      </p:sp>
-      <p:sp>
-        <p:nvSpPr>
-          <p:cNvPr id="16" name="TextBox 15"/>
-          <p:cNvSpPr txBox="1"/>
-          <p:nvPr/>
-        </p:nvSpPr>
-        <p:spPr>
-          <a:xfrm>
-            <a:off x="2758744" y="2377440"/>
-            <a:ext cx="7772400" cy="502920"/>
-          </a:xfrm>
-          <a:prstGeom prst="rect">
-            <a:avLst/>
-          </a:prstGeom>
-          <a:noFill/>
-        </p:spPr>
-        <p:txBody>
-          <a:bodyPr wrap="none">
-            <a:spAutoFit/>
-          </a:bodyPr>
-          <a:lstStyle/>
-          <a:p>
-            <a:pPr algn="l">
-              <a:spcAft>
-                <a:spcPts val="1000"/>
-              </a:spcAft>
-            </a:pPr>
-            <a:r>
-              <a:rPr sz="2400" b="0">
-                <a:solidFill>
-                  <a:srgbClr val="46325A"/>
-                </a:solidFill>
-                <a:latin typeface="Microsoft YaHei"/>
-              </a:rPr>
-              <a:t>尊重文本和生活的逻辑，看见习以为常之外的世界</a:t>
-            </a:r>
-          </a:p>
-        </p:txBody>
-      </p:sp>
-    </p:spTree>
-  </p:cSld>
-  <p:clrMapOvr>
-    <a:masterClrMapping/>
-  </p:clrMapOvr>
-</p:sld>
-</file>
-
-<file path=ppt/slides/slide9.xml><?xml version="1.0" encoding="utf-8"?>
-<p:sld xmlns:a="http://schemas.openxmlformats.org/drawingml/2006/main" xmlns:p="http://schemas.openxmlformats.org/presentationml/2006/main" xmlns:r="http://schemas.openxmlformats.org/officeDocument/2006/relationships">
-  <p:cSld>
-    <p:spTree>
-      <p:nvGrpSpPr>
-        <p:cNvPr id="1" name=""/>
-        <p:cNvGrpSpPr/>
-        <p:nvPr/>
-      </p:nvGrpSpPr>
-      <p:grpSpPr/>
-      <p:pic>
-        <p:nvPicPr>
-          <p:cNvPr id="2" name="Picture 1" descr="bg_final.png"/>
-          <p:cNvPicPr>
-            <a:picLocks noChangeAspect="1"/>
-          </p:cNvPicPr>
-          <p:nvPr/>
-        </p:nvPicPr>
-        <p:blipFill>
-          <a:blip r:embed="rId2"/>
-          <a:stretch>
-            <a:fillRect/>
-          </a:stretch>
-        </p:blipFill>
-        <p:spPr>
-          <a:xfrm>
-            <a:off x="0" y="0"/>
-            <a:ext cx="12191695" cy="6858000"/>
-          </a:xfrm>
-          <a:prstGeom prst="rect">
-            <a:avLst/>
-          </a:prstGeom>
-        </p:spPr>
-      </p:pic>
-      <p:sp>
-        <p:nvSpPr>
-          <p:cNvPr id="3" name="Rectangle 2"/>
-          <p:cNvSpPr/>
-          <p:nvPr/>
-        </p:nvSpPr>
-        <p:spPr>
-          <a:xfrm>
-            <a:off x="292608" y="274320"/>
-            <a:ext cx="11594592" cy="6300216"/>
-          </a:xfrm>
-          <a:prstGeom prst="rect">
-            <a:avLst/>
-          </a:prstGeom>
-          <a:noFill/>
-          <a:ln w="31750">
-            <a:solidFill>
-              <a:srgbClr val="B464B4"/>
-            </a:solidFill>
-          </a:ln>
-        </p:spPr>
-        <p:style>
-          <a:lnRef idx="1">
-            <a:schemeClr val="accent1"/>
-          </a:lnRef>
-          <a:fillRef idx="3">
-            <a:schemeClr val="accent1"/>
-          </a:fillRef>
-          <a:effectRef idx="2">
-            <a:schemeClr val="accent1"/>
-          </a:effectRef>
-          <a:fontRef idx="minor">
-            <a:schemeClr val="lt1"/>
-          </a:fontRef>
-        </p:style>
-        <p:txBody>
-          <a:bodyPr rtlCol="0" anchor="ctr"/>
-          <a:lstStyle/>
-          <a:p>
-            <a:pPr algn="ctr"/>
-          </a:p>
-        </p:txBody>
-      </p:sp>
-      <p:pic>
-        <p:nvPicPr>
-          <p:cNvPr id="4" name="Picture 3" descr="corner_final_tl.png"/>
-          <p:cNvPicPr>
-            <a:picLocks noChangeAspect="1"/>
-          </p:cNvPicPr>
-          <p:nvPr/>
-        </p:nvPicPr>
-        <p:blipFill>
-          <a:blip r:embed="rId3"/>
-          <a:stretch>
-            <a:fillRect/>
-          </a:stretch>
-        </p:blipFill>
-        <p:spPr>
-          <a:xfrm>
-            <a:off x="-45720" y="-45720"/>
-            <a:ext cx="2011680" cy="2011680"/>
-          </a:xfrm>
-          <a:prstGeom prst="rect">
-            <a:avLst/>
-          </a:prstGeom>
-        </p:spPr>
-      </p:pic>
-      <p:pic>
-        <p:nvPicPr>
-          <p:cNvPr id="5" name="Picture 4" descr="corner_final_tr.png"/>
-          <p:cNvPicPr>
-            <a:picLocks noChangeAspect="1"/>
-          </p:cNvPicPr>
-          <p:nvPr/>
-        </p:nvPicPr>
-        <p:blipFill>
-          <a:blip r:embed="rId4"/>
-          <a:stretch>
-            <a:fillRect/>
-          </a:stretch>
-        </p:blipFill>
-        <p:spPr>
-          <a:xfrm>
-            <a:off x="9875520" y="-45720"/>
-            <a:ext cx="2011680" cy="2011680"/>
-          </a:xfrm>
-          <a:prstGeom prst="rect">
-            <a:avLst/>
-          </a:prstGeom>
-        </p:spPr>
-      </p:pic>
-      <p:sp>
-        <p:nvSpPr>
-          <p:cNvPr id="6" name="Rounded Rectangle 5"/>
-          <p:cNvSpPr/>
-          <p:nvPr/>
-        </p:nvSpPr>
-        <p:spPr>
-          <a:xfrm>
-            <a:off x="4953304" y="502920"/>
-            <a:ext cx="2286000" cy="411480"/>
-          </a:xfrm>
-          <a:prstGeom prst="roundRect">
-            <a:avLst/>
-          </a:prstGeom>
-          <a:solidFill>
-            <a:srgbClr val="64C8DC"/>
-          </a:solidFill>
-          <a:ln>
-            <a:noFill/>
-          </a:ln>
-        </p:spPr>
-        <p:style>
-          <a:lnRef idx="1">
-            <a:schemeClr val="accent1"/>
-          </a:lnRef>
-          <a:fillRef idx="3">
-            <a:schemeClr val="accent1"/>
-          </a:fillRef>
-          <a:effectRef idx="2">
-            <a:schemeClr val="accent1"/>
-          </a:effectRef>
-          <a:fontRef idx="minor">
-            <a:schemeClr val="lt1"/>
-          </a:fontRef>
-        </p:style>
-        <p:txBody>
-          <a:bodyPr rtlCol="0" anchor="ctr"/>
-          <a:lstStyle/>
-          <a:p>
-            <a:pPr algn="ctr"/>
-          </a:p>
-        </p:txBody>
-      </p:sp>
-      <p:sp>
-        <p:nvSpPr>
-          <p:cNvPr id="7" name="TextBox 6"/>
-          <p:cNvSpPr txBox="1"/>
-          <p:nvPr/>
-        </p:nvSpPr>
-        <p:spPr>
-          <a:xfrm>
-            <a:off x="4953304" y="521208"/>
-            <a:ext cx="2286000" cy="384048"/>
-          </a:xfrm>
-          <a:prstGeom prst="rect">
-            <a:avLst/>
-          </a:prstGeom>
-          <a:noFill/>
-        </p:spPr>
-        <p:txBody>
-          <a:bodyPr wrap="none">
-            <a:spAutoFit/>
-          </a:bodyPr>
-          <a:lstStyle/>
-          <a:p>
-            <a:pPr algn="ctr">
-              <a:spcAft>
-                <a:spcPts val="1000"/>
-              </a:spcAft>
-            </a:pPr>
-            <a:r>
-              <a:rPr sz="1800" b="1">
-                <a:solidFill>
-                  <a:srgbClr val="46325A"/>
-                </a:solidFill>
-                <a:latin typeface="Microsoft YaHei"/>
-              </a:rPr>
-              <a:t>课后延伸</a:t>
-            </a:r>
-          </a:p>
-        </p:txBody>
-      </p:sp>
-      <p:sp>
-        <p:nvSpPr>
-          <p:cNvPr id="8" name="TextBox 7"/>
-          <p:cNvSpPr txBox="1"/>
-          <p:nvPr/>
-        </p:nvSpPr>
-        <p:spPr>
-          <a:xfrm>
-            <a:off x="1371600" y="960120"/>
-            <a:ext cx="9418320" cy="822960"/>
-          </a:xfrm>
-          <a:prstGeom prst="rect">
-            <a:avLst/>
-          </a:prstGeom>
-          <a:noFill/>
-        </p:spPr>
-        <p:txBody>
-          <a:bodyPr wrap="square">
-            <a:spAutoFit/>
-          </a:bodyPr>
-          <a:lstStyle/>
-          <a:p>
-            <a:pPr algn="ctr">
-              <a:spcAft>
-                <a:spcPts val="1000"/>
-              </a:spcAft>
-            </a:pPr>
-            <a:r>
-              <a:rPr sz="3600" b="1">
+              <a:rPr sz="2200" b="1">
                 <a:solidFill>
                   <a:srgbClr val="E65096"/>
                 </a:solidFill>
@@ -8218,184 +6598,14 @@
       </p:sp>
       <p:sp>
         <p:nvSpPr>
-          <p:cNvPr id="9" name="Rectangle 8"/>
-          <p:cNvSpPr/>
-          <p:nvPr/>
-        </p:nvSpPr>
-        <p:spPr>
-          <a:xfrm>
-            <a:off x="3200400" y="1600200"/>
-            <a:ext cx="5760720" cy="27432"/>
-          </a:xfrm>
-          <a:prstGeom prst="rect">
-            <a:avLst/>
-          </a:prstGeom>
-          <a:solidFill>
-            <a:srgbClr val="64C8DC"/>
-          </a:solidFill>
-          <a:ln>
-            <a:noFill/>
-          </a:ln>
-        </p:spPr>
-        <p:style>
-          <a:lnRef idx="1">
-            <a:schemeClr val="accent1"/>
-          </a:lnRef>
-          <a:fillRef idx="3">
-            <a:schemeClr val="accent1"/>
-          </a:fillRef>
-          <a:effectRef idx="2">
-            <a:schemeClr val="accent1"/>
-          </a:effectRef>
-          <a:fontRef idx="minor">
-            <a:schemeClr val="lt1"/>
-          </a:fontRef>
-        </p:style>
-        <p:txBody>
-          <a:bodyPr rtlCol="0" anchor="ctr"/>
-          <a:lstStyle/>
-          <a:p>
-            <a:pPr algn="ctr"/>
-          </a:p>
-        </p:txBody>
-      </p:sp>
-      <p:sp>
-        <p:nvSpPr>
-          <p:cNvPr id="10" name="Rounded Rectangle 9"/>
-          <p:cNvSpPr/>
-          <p:nvPr/>
-        </p:nvSpPr>
-        <p:spPr>
-          <a:xfrm>
-            <a:off x="1295704" y="1645920"/>
-            <a:ext cx="9601200" cy="2240280"/>
-          </a:xfrm>
-          <a:prstGeom prst="roundRect">
-            <a:avLst/>
-          </a:prstGeom>
-          <a:solidFill>
-            <a:srgbClr val="FFFAFF"/>
-          </a:solidFill>
-          <a:ln w="19050">
-            <a:solidFill>
-              <a:srgbClr val="64C8DC"/>
-            </a:solidFill>
-          </a:ln>
-        </p:spPr>
-        <p:style>
-          <a:lnRef idx="1">
-            <a:schemeClr val="accent1"/>
-          </a:lnRef>
-          <a:fillRef idx="3">
-            <a:schemeClr val="accent1"/>
-          </a:fillRef>
-          <a:effectRef idx="2">
-            <a:schemeClr val="accent1"/>
-          </a:effectRef>
-          <a:fontRef idx="minor">
-            <a:schemeClr val="lt1"/>
-          </a:fontRef>
-        </p:style>
-        <p:txBody>
-          <a:bodyPr rtlCol="0" anchor="ctr"/>
-          <a:lstStyle/>
-          <a:p>
-            <a:pPr algn="ctr"/>
-          </a:p>
-        </p:txBody>
-      </p:sp>
-      <p:sp>
-        <p:nvSpPr>
-          <p:cNvPr id="11" name="Oval 10"/>
-          <p:cNvSpPr/>
-          <p:nvPr/>
-        </p:nvSpPr>
-        <p:spPr>
-          <a:xfrm>
-            <a:off x="2255824" y="1828800"/>
-            <a:ext cx="384048" cy="384048"/>
-          </a:xfrm>
-          <a:prstGeom prst="ellipse">
-            <a:avLst/>
-          </a:prstGeom>
-          <a:solidFill>
-            <a:srgbClr val="E65096"/>
-          </a:solidFill>
-          <a:ln>
-            <a:noFill/>
-          </a:ln>
-        </p:spPr>
-        <p:style>
-          <a:lnRef idx="1">
-            <a:schemeClr val="accent1"/>
-          </a:lnRef>
-          <a:fillRef idx="3">
-            <a:schemeClr val="accent1"/>
-          </a:fillRef>
-          <a:effectRef idx="2">
-            <a:schemeClr val="accent1"/>
-          </a:effectRef>
-          <a:fontRef idx="minor">
-            <a:schemeClr val="lt1"/>
-          </a:fontRef>
-        </p:style>
-        <p:txBody>
-          <a:bodyPr rtlCol="0" anchor="ctr"/>
-          <a:lstStyle/>
-          <a:p>
-            <a:pPr algn="ctr"/>
-          </a:p>
-        </p:txBody>
-      </p:sp>
-      <p:sp>
-        <p:nvSpPr>
-          <p:cNvPr id="12" name="TextBox 11"/>
+          <p:cNvPr id="16" name="TextBox 15"/>
           <p:cNvSpPr txBox="1"/>
           <p:nvPr/>
         </p:nvSpPr>
         <p:spPr>
           <a:xfrm>
-            <a:off x="2255824" y="1847088"/>
-            <a:ext cx="384048" cy="365760"/>
-          </a:xfrm>
-          <a:prstGeom prst="rect">
-            <a:avLst/>
-          </a:prstGeom>
-          <a:noFill/>
-        </p:spPr>
-        <p:txBody>
-          <a:bodyPr wrap="none">
-            <a:spAutoFit/>
-          </a:bodyPr>
-          <a:lstStyle/>
-          <a:p>
-            <a:pPr algn="ctr">
-              <a:spcAft>
-                <a:spcPts val="1000"/>
-              </a:spcAft>
-            </a:pPr>
-            <a:r>
-              <a:rPr sz="1600" b="1">
-                <a:solidFill>
-                  <a:srgbClr val="FFFFFF"/>
-                </a:solidFill>
-                <a:latin typeface="Microsoft YaHei"/>
-              </a:rPr>
-              <a:t>1</a:t>
-            </a:r>
-          </a:p>
-        </p:txBody>
-      </p:sp>
-      <p:sp>
-        <p:nvSpPr>
-          <p:cNvPr id="13" name="TextBox 12"/>
-          <p:cNvSpPr txBox="1"/>
-          <p:nvPr/>
-        </p:nvSpPr>
-        <p:spPr>
-          <a:xfrm>
-            <a:off x="2758744" y="1810512"/>
-            <a:ext cx="7772400" cy="502920"/>
+            <a:off x="3749039" y="3099815"/>
+            <a:ext cx="7589520" cy="594360"/>
           </a:xfrm>
           <a:prstGeom prst="rect">
             <a:avLst/>
@@ -8414,70 +6624,27 @@
               </a:spcAft>
             </a:pPr>
             <a:r>
-              <a:rPr sz="2400" b="0">
+              <a:rPr sz="2200" b="0">
                 <a:solidFill>
                   <a:srgbClr val="46325A"/>
                 </a:solidFill>
                 <a:latin typeface="Microsoft YaHei"/>
               </a:rPr>
-              <a:t>阅读：完善策展卡，600字想象主题作文</a:t>
-            </a:r>
-          </a:p>
-        </p:txBody>
-      </p:sp>
-      <p:sp>
-        <p:nvSpPr>
-          <p:cNvPr id="14" name="Oval 13"/>
-          <p:cNvSpPr/>
-          <p:nvPr/>
-        </p:nvSpPr>
-        <p:spPr>
-          <a:xfrm>
-            <a:off x="2255824" y="2395728"/>
-            <a:ext cx="384048" cy="384048"/>
-          </a:xfrm>
-          <a:prstGeom prst="ellipse">
-            <a:avLst/>
-          </a:prstGeom>
-          <a:solidFill>
-            <a:srgbClr val="E65096"/>
-          </a:solidFill>
-          <a:ln>
-            <a:noFill/>
-          </a:ln>
-        </p:spPr>
-        <p:style>
-          <a:lnRef idx="1">
-            <a:schemeClr val="accent1"/>
-          </a:lnRef>
-          <a:fillRef idx="3">
-            <a:schemeClr val="accent1"/>
-          </a:fillRef>
-          <a:effectRef idx="2">
-            <a:schemeClr val="accent1"/>
-          </a:effectRef>
-          <a:fontRef idx="minor">
-            <a:schemeClr val="lt1"/>
-          </a:fontRef>
-        </p:style>
-        <p:txBody>
-          <a:bodyPr rtlCol="0" anchor="ctr"/>
-          <a:lstStyle/>
-          <a:p>
-            <a:pPr algn="ctr"/>
-          </a:p>
-        </p:txBody>
-      </p:sp>
-      <p:sp>
-        <p:nvSpPr>
-          <p:cNvPr id="15" name="TextBox 14"/>
+              <a:t>600字想象作文，或5分钟课本剧脚本</a:t>
+            </a:r>
+          </a:p>
+        </p:txBody>
+      </p:sp>
+      <p:sp>
+        <p:nvSpPr>
+          <p:cNvPr id="17" name="TextBox 16"/>
           <p:cNvSpPr txBox="1"/>
           <p:nvPr/>
         </p:nvSpPr>
         <p:spPr>
           <a:xfrm>
-            <a:off x="2255824" y="2414016"/>
-            <a:ext cx="384048" cy="365760"/>
+            <a:off x="1234440" y="3758184"/>
+            <a:ext cx="2377440" cy="502920"/>
           </a:xfrm>
           <a:prstGeom prst="rect">
             <a:avLst/>
@@ -8490,33 +6657,33 @@
           </a:bodyPr>
           <a:lstStyle/>
           <a:p>
-            <a:pPr algn="ctr">
+            <a:pPr algn="r">
               <a:spcAft>
                 <a:spcPts val="1000"/>
               </a:spcAft>
             </a:pPr>
             <a:r>
-              <a:rPr sz="1600" b="1">
+              <a:rPr sz="2200" b="1">
                 <a:solidFill>
-                  <a:srgbClr val="FFFFFF"/>
+                  <a:srgbClr val="E65096"/>
                 </a:solidFill>
                 <a:latin typeface="Microsoft YaHei"/>
               </a:rPr>
-              <a:t>2</a:t>
-            </a:r>
-          </a:p>
-        </p:txBody>
-      </p:sp>
-      <p:sp>
-        <p:nvSpPr>
-          <p:cNvPr id="16" name="TextBox 15"/>
+              <a:t>要求</a:t>
+            </a:r>
+          </a:p>
+        </p:txBody>
+      </p:sp>
+      <p:sp>
+        <p:nvSpPr>
+          <p:cNvPr id="18" name="TextBox 17"/>
           <p:cNvSpPr txBox="1"/>
           <p:nvPr/>
         </p:nvSpPr>
         <p:spPr>
           <a:xfrm>
-            <a:off x="2758744" y="2377440"/>
-            <a:ext cx="7772400" cy="502920"/>
+            <a:off x="3749039" y="3758184"/>
+            <a:ext cx="7589520" cy="594360"/>
           </a:xfrm>
           <a:prstGeom prst="rect">
             <a:avLst/>
@@ -8535,134 +6702,13 @@
               </a:spcAft>
             </a:pPr>
             <a:r>
-              <a:rPr sz="2400" b="0">
+              <a:rPr sz="2200" b="0">
                 <a:solidFill>
                   <a:srgbClr val="46325A"/>
                 </a:solidFill>
                 <a:latin typeface="Microsoft YaHei"/>
               </a:rPr>
-              <a:t>或：5分钟以内课本剧脚本</a:t>
-            </a:r>
-          </a:p>
-        </p:txBody>
-      </p:sp>
-      <p:sp>
-        <p:nvSpPr>
-          <p:cNvPr id="17" name="Oval 16"/>
-          <p:cNvSpPr/>
-          <p:nvPr/>
-        </p:nvSpPr>
-        <p:spPr>
-          <a:xfrm>
-            <a:off x="2255824" y="2962656"/>
-            <a:ext cx="384048" cy="384048"/>
-          </a:xfrm>
-          <a:prstGeom prst="ellipse">
-            <a:avLst/>
-          </a:prstGeom>
-          <a:solidFill>
-            <a:srgbClr val="E65096"/>
-          </a:solidFill>
-          <a:ln>
-            <a:noFill/>
-          </a:ln>
-        </p:spPr>
-        <p:style>
-          <a:lnRef idx="1">
-            <a:schemeClr val="accent1"/>
-          </a:lnRef>
-          <a:fillRef idx="3">
-            <a:schemeClr val="accent1"/>
-          </a:fillRef>
-          <a:effectRef idx="2">
-            <a:schemeClr val="accent1"/>
-          </a:effectRef>
-          <a:fontRef idx="minor">
-            <a:schemeClr val="lt1"/>
-          </a:fontRef>
-        </p:style>
-        <p:txBody>
-          <a:bodyPr rtlCol="0" anchor="ctr"/>
-          <a:lstStyle/>
-          <a:p>
-            <a:pPr algn="ctr"/>
-          </a:p>
-        </p:txBody>
-      </p:sp>
-      <p:sp>
-        <p:nvSpPr>
-          <p:cNvPr id="18" name="TextBox 17"/>
-          <p:cNvSpPr txBox="1"/>
-          <p:nvPr/>
-        </p:nvSpPr>
-        <p:spPr>
-          <a:xfrm>
-            <a:off x="2255824" y="2980944"/>
-            <a:ext cx="384048" cy="365760"/>
-          </a:xfrm>
-          <a:prstGeom prst="rect">
-            <a:avLst/>
-          </a:prstGeom>
-          <a:noFill/>
-        </p:spPr>
-        <p:txBody>
-          <a:bodyPr wrap="none">
-            <a:spAutoFit/>
-          </a:bodyPr>
-          <a:lstStyle/>
-          <a:p>
-            <a:pPr algn="ctr">
-              <a:spcAft>
-                <a:spcPts val="1000"/>
-              </a:spcAft>
-            </a:pPr>
-            <a:r>
-              <a:rPr sz="1600" b="1">
-                <a:solidFill>
-                  <a:srgbClr val="FFFFFF"/>
-                </a:solidFill>
-                <a:latin typeface="Microsoft YaHei"/>
-              </a:rPr>
-              <a:t>3</a:t>
-            </a:r>
-          </a:p>
-        </p:txBody>
-      </p:sp>
-      <p:sp>
-        <p:nvSpPr>
-          <p:cNvPr id="19" name="TextBox 18"/>
-          <p:cNvSpPr txBox="1"/>
-          <p:nvPr/>
-        </p:nvSpPr>
-        <p:spPr>
-          <a:xfrm>
-            <a:off x="2758744" y="2944368"/>
-            <a:ext cx="7772400" cy="502920"/>
-          </a:xfrm>
-          <a:prstGeom prst="rect">
-            <a:avLst/>
-          </a:prstGeom>
-          <a:noFill/>
-        </p:spPr>
-        <p:txBody>
-          <a:bodyPr wrap="none">
-            <a:spAutoFit/>
-          </a:bodyPr>
-          <a:lstStyle/>
-          <a:p>
-            <a:pPr algn="l">
-              <a:spcAft>
-                <a:spcPts val="1000"/>
-              </a:spcAft>
-            </a:pPr>
-            <a:r>
-              <a:rPr sz="2400" b="0">
-                <a:solidFill>
-                  <a:srgbClr val="46325A"/>
-                </a:solidFill>
-                <a:latin typeface="Microsoft YaHei"/>
-              </a:rPr>
-              <a:t>要求：有依据、合逻辑、有新意，体现策展主题</a:t>
+              <a:t>有依据、合逻辑、有新意，体现策展主题</a:t>
             </a:r>
           </a:p>
         </p:txBody>

</xml_diff>